<commit_message>
Add Slide 11 content map and fix cross-platform save path
- Added Slide 11 (Content Map / Mind Map) showing Birch Wilson digital experience data categories by site section
- Replaced Windows-specific hardcoded output path with cross-platform os.path approach
- Removed Windows-only COM/PDF export code

Co-Authored-By: Claude Sonnet 4.6 <noreply@anthropic.com>
</commit_message>
<xml_diff>
--- a/LacroixJohn_Assignment3_BirchWilson.pptx
+++ b/LacroixJohn_Assignment3_BirchWilson.pptx
@@ -15,6 +15,7 @@
     <p:sldId id="263" r:id="rId14"/>
     <p:sldId id="264" r:id="rId15"/>
     <p:sldId id="265" r:id="rId16"/>
+    <p:sldId id="266" r:id="rId17"/>
   </p:sldIdLst>
   <p:sldSz cx="12188952" cy="6858000" type="screen4x3"/>
   <p:notesSz cx="6858000" cy="9144000"/>
@@ -5318,6 +5319,4616 @@
       <p:sp>
         <p:nvSpPr>
           <p:cNvPr id="50" name="Rectangle 49"/>
+          <p:cNvSpPr/>
+          <p:nvPr/>
+        </p:nvSpPr>
+        <p:spPr>
+          <a:xfrm>
+            <a:off x="0" y="6812280"/>
+            <a:ext cx="12188952" cy="45720"/>
+          </a:xfrm>
+          <a:prstGeom prst="rect">
+            <a:avLst/>
+          </a:prstGeom>
+          <a:solidFill>
+            <a:srgbClr val="4A90E2"/>
+          </a:solidFill>
+          <a:ln>
+            <a:noFill/>
+          </a:ln>
+        </p:spPr>
+        <p:style>
+          <a:lnRef idx="1">
+            <a:schemeClr val="accent1"/>
+          </a:lnRef>
+          <a:fillRef idx="3">
+            <a:schemeClr val="accent1"/>
+          </a:fillRef>
+          <a:effectRef idx="2">
+            <a:schemeClr val="accent1"/>
+          </a:effectRef>
+          <a:fontRef idx="minor">
+            <a:schemeClr val="lt1"/>
+          </a:fontRef>
+        </p:style>
+        <p:txBody>
+          <a:bodyPr rtlCol="0" anchor="ctr"/>
+          <a:lstStyle/>
+          <a:p>
+            <a:pPr algn="ctr"/>
+          </a:p>
+        </p:txBody>
+      </p:sp>
+    </p:spTree>
+  </p:cSld>
+  <p:clrMapOvr>
+    <a:masterClrMapping/>
+  </p:clrMapOvr>
+</p:sld>
+</file>
+
+<file path=ppt/slides/slide11.xml><?xml version="1.0" encoding="utf-8"?>
+<p:sld xmlns:a="http://schemas.openxmlformats.org/drawingml/2006/main" xmlns:p="http://schemas.openxmlformats.org/presentationml/2006/main" xmlns:r="http://schemas.openxmlformats.org/officeDocument/2006/relationships">
+  <p:cSld>
+    <p:bg>
+      <p:bgPr>
+        <a:solidFill>
+          <a:srgbClr val="F7F9FB"/>
+        </a:solidFill>
+        <a:effectLst/>
+      </p:bgPr>
+    </p:bg>
+    <p:spTree>
+      <p:nvGrpSpPr>
+        <p:cNvPr id="1" name=""/>
+        <p:cNvGrpSpPr/>
+        <p:nvPr/>
+      </p:nvGrpSpPr>
+      <p:grpSpPr/>
+      <p:sp>
+        <p:nvSpPr>
+          <p:cNvPr id="2" name="Rectangle 1"/>
+          <p:cNvSpPr/>
+          <p:nvPr/>
+        </p:nvSpPr>
+        <p:spPr>
+          <a:xfrm>
+            <a:off x="0" y="0"/>
+            <a:ext cx="12188952" cy="45720"/>
+          </a:xfrm>
+          <a:prstGeom prst="rect">
+            <a:avLst/>
+          </a:prstGeom>
+          <a:solidFill>
+            <a:srgbClr val="4A90E2"/>
+          </a:solidFill>
+          <a:ln>
+            <a:noFill/>
+          </a:ln>
+        </p:spPr>
+        <p:style>
+          <a:lnRef idx="1">
+            <a:schemeClr val="accent1"/>
+          </a:lnRef>
+          <a:fillRef idx="3">
+            <a:schemeClr val="accent1"/>
+          </a:fillRef>
+          <a:effectRef idx="2">
+            <a:schemeClr val="accent1"/>
+          </a:effectRef>
+          <a:fontRef idx="minor">
+            <a:schemeClr val="lt1"/>
+          </a:fontRef>
+        </p:style>
+        <p:txBody>
+          <a:bodyPr rtlCol="0" anchor="ctr"/>
+          <a:lstStyle/>
+          <a:p>
+            <a:pPr algn="ctr"/>
+          </a:p>
+        </p:txBody>
+      </p:sp>
+      <p:sp>
+        <p:nvSpPr>
+          <p:cNvPr id="3" name="TextBox 2"/>
+          <p:cNvSpPr txBox="1"/>
+          <p:nvPr/>
+        </p:nvSpPr>
+        <p:spPr>
+          <a:xfrm>
+            <a:off x="457200" y="109728"/>
+            <a:ext cx="3657600" cy="274320"/>
+          </a:xfrm>
+          <a:prstGeom prst="rect">
+            <a:avLst/>
+          </a:prstGeom>
+          <a:noFill/>
+        </p:spPr>
+        <p:txBody>
+          <a:bodyPr wrap="square">
+            <a:spAutoFit/>
+          </a:bodyPr>
+          <a:lstStyle/>
+          <a:p>
+            <a:pPr algn="l"/>
+            <a:r>
+              <a:rPr sz="900" b="1" i="0">
+                <a:solidFill>
+                  <a:srgbClr val="6B7280"/>
+                </a:solidFill>
+                <a:latin typeface="Segoe UI"/>
+              </a:rPr>
+              <a:t>CONTENT MAP</a:t>
+            </a:r>
+          </a:p>
+        </p:txBody>
+      </p:sp>
+      <p:sp>
+        <p:nvSpPr>
+          <p:cNvPr id="4" name="Rectangle 3"/>
+          <p:cNvSpPr/>
+          <p:nvPr/>
+        </p:nvSpPr>
+        <p:spPr>
+          <a:xfrm>
+            <a:off x="457200" y="438912"/>
+            <a:ext cx="11274552" cy="16459"/>
+          </a:xfrm>
+          <a:prstGeom prst="rect">
+            <a:avLst/>
+          </a:prstGeom>
+          <a:solidFill>
+            <a:srgbClr val="D1D9E3"/>
+          </a:solidFill>
+          <a:ln>
+            <a:noFill/>
+          </a:ln>
+        </p:spPr>
+        <p:style>
+          <a:lnRef idx="1">
+            <a:schemeClr val="accent1"/>
+          </a:lnRef>
+          <a:fillRef idx="3">
+            <a:schemeClr val="accent1"/>
+          </a:fillRef>
+          <a:effectRef idx="2">
+            <a:schemeClr val="accent1"/>
+          </a:effectRef>
+          <a:fontRef idx="minor">
+            <a:schemeClr val="lt1"/>
+          </a:fontRef>
+        </p:style>
+        <p:txBody>
+          <a:bodyPr rtlCol="0" anchor="ctr"/>
+          <a:lstStyle/>
+          <a:p>
+            <a:pPr algn="ctr"/>
+          </a:p>
+        </p:txBody>
+      </p:sp>
+      <p:sp>
+        <p:nvSpPr>
+          <p:cNvPr id="5" name="TextBox 4"/>
+          <p:cNvSpPr txBox="1"/>
+          <p:nvPr/>
+        </p:nvSpPr>
+        <p:spPr>
+          <a:xfrm>
+            <a:off x="457200" y="493776"/>
+            <a:ext cx="11274552" cy="347472"/>
+          </a:xfrm>
+          <a:prstGeom prst="rect">
+            <a:avLst/>
+          </a:prstGeom>
+          <a:noFill/>
+        </p:spPr>
+        <p:txBody>
+          <a:bodyPr wrap="square">
+            <a:spAutoFit/>
+          </a:bodyPr>
+          <a:lstStyle/>
+          <a:p>
+            <a:pPr algn="l"/>
+            <a:r>
+              <a:rPr sz="1500" b="1" i="0">
+                <a:solidFill>
+                  <a:srgbClr val="1A1A1A"/>
+                </a:solidFill>
+                <a:latin typeface="Segoe UI"/>
+              </a:rPr>
+              <a:t>Birch Wilson Digital Experience  ·  Data &amp; Content Categories by Site Section</a:t>
+            </a:r>
+          </a:p>
+        </p:txBody>
+      </p:sp>
+      <p:sp>
+        <p:nvSpPr>
+          <p:cNvPr id="6" name="Rounded Rectangle 5"/>
+          <p:cNvSpPr/>
+          <p:nvPr/>
+        </p:nvSpPr>
+        <p:spPr>
+          <a:xfrm>
+            <a:off x="228600" y="3236976"/>
+            <a:ext cx="1417320" cy="457200"/>
+          </a:xfrm>
+          <a:prstGeom prst="roundRect">
+            <a:avLst/>
+          </a:prstGeom>
+          <a:solidFill>
+            <a:srgbClr val="1A1A1A"/>
+          </a:solidFill>
+          <a:ln w="12700">
+            <a:solidFill>
+              <a:srgbClr val="1A1A1A"/>
+            </a:solidFill>
+          </a:ln>
+        </p:spPr>
+        <p:style>
+          <a:lnRef idx="1">
+            <a:schemeClr val="accent1"/>
+          </a:lnRef>
+          <a:fillRef idx="3">
+            <a:schemeClr val="accent1"/>
+          </a:fillRef>
+          <a:effectRef idx="2">
+            <a:schemeClr val="accent1"/>
+          </a:effectRef>
+          <a:fontRef idx="minor">
+            <a:schemeClr val="lt1"/>
+          </a:fontRef>
+        </p:style>
+        <p:txBody>
+          <a:bodyPr rtlCol="0" anchor="ctr"/>
+          <a:lstStyle/>
+          <a:p>
+            <a:pPr algn="ctr"/>
+          </a:p>
+        </p:txBody>
+      </p:sp>
+      <p:sp>
+        <p:nvSpPr>
+          <p:cNvPr id="7" name="TextBox 6"/>
+          <p:cNvSpPr txBox="1"/>
+          <p:nvPr/>
+        </p:nvSpPr>
+        <p:spPr>
+          <a:xfrm>
+            <a:off x="228600" y="3236976"/>
+            <a:ext cx="1417320" cy="457200"/>
+          </a:xfrm>
+          <a:prstGeom prst="rect">
+            <a:avLst/>
+          </a:prstGeom>
+          <a:noFill/>
+        </p:spPr>
+        <p:txBody>
+          <a:bodyPr wrap="square">
+            <a:spAutoFit/>
+          </a:bodyPr>
+          <a:lstStyle/>
+          <a:p>
+            <a:pPr algn="ctr"/>
+            <a:r>
+              <a:rPr sz="1000" b="1" i="0">
+                <a:solidFill>
+                  <a:srgbClr val="FFFFFF"/>
+                </a:solidFill>
+                <a:latin typeface="Segoe UI"/>
+              </a:rPr>
+              <a:t>BIRCH
+WILSON</a:t>
+            </a:r>
+          </a:p>
+        </p:txBody>
+      </p:sp>
+      <p:sp>
+        <p:nvSpPr>
+          <p:cNvPr id="8" name="Rectangle 7"/>
+          <p:cNvSpPr/>
+          <p:nvPr/>
+        </p:nvSpPr>
+        <p:spPr>
+          <a:xfrm>
+            <a:off x="1881835" y="1051560"/>
+            <a:ext cx="20116" cy="4841747"/>
+          </a:xfrm>
+          <a:prstGeom prst="rect">
+            <a:avLst/>
+          </a:prstGeom>
+          <a:solidFill>
+            <a:srgbClr val="B8C5D3"/>
+          </a:solidFill>
+          <a:ln>
+            <a:noFill/>
+          </a:ln>
+        </p:spPr>
+        <p:style>
+          <a:lnRef idx="1">
+            <a:schemeClr val="accent1"/>
+          </a:lnRef>
+          <a:fillRef idx="3">
+            <a:schemeClr val="accent1"/>
+          </a:fillRef>
+          <a:effectRef idx="2">
+            <a:schemeClr val="accent1"/>
+          </a:effectRef>
+          <a:fontRef idx="minor">
+            <a:schemeClr val="lt1"/>
+          </a:fontRef>
+        </p:style>
+        <p:txBody>
+          <a:bodyPr rtlCol="0" anchor="ctr"/>
+          <a:lstStyle/>
+          <a:p>
+            <a:pPr algn="ctr"/>
+          </a:p>
+        </p:txBody>
+      </p:sp>
+      <p:sp>
+        <p:nvSpPr>
+          <p:cNvPr id="9" name="Rectangle 8"/>
+          <p:cNvSpPr/>
+          <p:nvPr/>
+        </p:nvSpPr>
+        <p:spPr>
+          <a:xfrm>
+            <a:off x="1645920" y="3454603"/>
+            <a:ext cx="260603" cy="20116"/>
+          </a:xfrm>
+          <a:prstGeom prst="rect">
+            <a:avLst/>
+          </a:prstGeom>
+          <a:solidFill>
+            <a:srgbClr val="B8C5D3"/>
+          </a:solidFill>
+          <a:ln>
+            <a:noFill/>
+          </a:ln>
+        </p:spPr>
+        <p:style>
+          <a:lnRef idx="1">
+            <a:schemeClr val="accent1"/>
+          </a:lnRef>
+          <a:fillRef idx="3">
+            <a:schemeClr val="accent1"/>
+          </a:fillRef>
+          <a:effectRef idx="2">
+            <a:schemeClr val="accent1"/>
+          </a:effectRef>
+          <a:fontRef idx="minor">
+            <a:schemeClr val="lt1"/>
+          </a:fontRef>
+        </p:style>
+        <p:txBody>
+          <a:bodyPr rtlCol="0" anchor="ctr"/>
+          <a:lstStyle/>
+          <a:p>
+            <a:pPr algn="ctr"/>
+          </a:p>
+        </p:txBody>
+      </p:sp>
+      <p:sp>
+        <p:nvSpPr>
+          <p:cNvPr id="10" name="Rectangle 9"/>
+          <p:cNvSpPr/>
+          <p:nvPr/>
+        </p:nvSpPr>
+        <p:spPr>
+          <a:xfrm>
+            <a:off x="1892807" y="1040587"/>
+            <a:ext cx="86868" cy="20116"/>
+          </a:xfrm>
+          <a:prstGeom prst="rect">
+            <a:avLst/>
+          </a:prstGeom>
+          <a:solidFill>
+            <a:srgbClr val="5FA8A0"/>
+          </a:solidFill>
+          <a:ln>
+            <a:noFill/>
+          </a:ln>
+        </p:spPr>
+        <p:style>
+          <a:lnRef idx="1">
+            <a:schemeClr val="accent1"/>
+          </a:lnRef>
+          <a:fillRef idx="3">
+            <a:schemeClr val="accent1"/>
+          </a:fillRef>
+          <a:effectRef idx="2">
+            <a:schemeClr val="accent1"/>
+          </a:effectRef>
+          <a:fontRef idx="minor">
+            <a:schemeClr val="lt1"/>
+          </a:fontRef>
+        </p:style>
+        <p:txBody>
+          <a:bodyPr rtlCol="0" anchor="ctr"/>
+          <a:lstStyle/>
+          <a:p>
+            <a:pPr algn="ctr"/>
+          </a:p>
+        </p:txBody>
+      </p:sp>
+      <p:sp>
+        <p:nvSpPr>
+          <p:cNvPr id="11" name="Rounded Rectangle 10"/>
+          <p:cNvSpPr/>
+          <p:nvPr/>
+        </p:nvSpPr>
+        <p:spPr>
+          <a:xfrm>
+            <a:off x="1965960" y="859536"/>
+            <a:ext cx="1463040" cy="384048"/>
+          </a:xfrm>
+          <a:prstGeom prst="roundRect">
+            <a:avLst/>
+          </a:prstGeom>
+          <a:solidFill>
+            <a:srgbClr val="5FA8A0"/>
+          </a:solidFill>
+          <a:ln w="12700">
+            <a:solidFill>
+              <a:srgbClr val="5FA8A0"/>
+            </a:solidFill>
+          </a:ln>
+        </p:spPr>
+        <p:style>
+          <a:lnRef idx="1">
+            <a:schemeClr val="accent1"/>
+          </a:lnRef>
+          <a:fillRef idx="3">
+            <a:schemeClr val="accent1"/>
+          </a:fillRef>
+          <a:effectRef idx="2">
+            <a:schemeClr val="accent1"/>
+          </a:effectRef>
+          <a:fontRef idx="minor">
+            <a:schemeClr val="lt1"/>
+          </a:fontRef>
+        </p:style>
+        <p:txBody>
+          <a:bodyPr rtlCol="0" anchor="ctr"/>
+          <a:lstStyle/>
+          <a:p>
+            <a:pPr algn="ctr"/>
+          </a:p>
+        </p:txBody>
+      </p:sp>
+      <p:sp>
+        <p:nvSpPr>
+          <p:cNvPr id="12" name="TextBox 11"/>
+          <p:cNvSpPr txBox="1"/>
+          <p:nvPr/>
+        </p:nvSpPr>
+        <p:spPr>
+          <a:xfrm>
+            <a:off x="1965960" y="859536"/>
+            <a:ext cx="1463040" cy="384048"/>
+          </a:xfrm>
+          <a:prstGeom prst="rect">
+            <a:avLst/>
+          </a:prstGeom>
+          <a:noFill/>
+        </p:spPr>
+        <p:txBody>
+          <a:bodyPr wrap="square">
+            <a:spAutoFit/>
+          </a:bodyPr>
+          <a:lstStyle/>
+          <a:p>
+            <a:pPr algn="ctr"/>
+            <a:r>
+              <a:rPr sz="900" b="1" i="0">
+                <a:solidFill>
+                  <a:srgbClr val="FFFFFF"/>
+                </a:solidFill>
+                <a:latin typeface="Segoe UI"/>
+              </a:rPr>
+              <a:t>Artist</a:t>
+            </a:r>
+          </a:p>
+        </p:txBody>
+      </p:sp>
+      <p:sp>
+        <p:nvSpPr>
+          <p:cNvPr id="13" name="Rectangle 12"/>
+          <p:cNvSpPr/>
+          <p:nvPr/>
+        </p:nvSpPr>
+        <p:spPr>
+          <a:xfrm>
+            <a:off x="3619195" y="667511"/>
+            <a:ext cx="20116" cy="781812"/>
+          </a:xfrm>
+          <a:prstGeom prst="rect">
+            <a:avLst/>
+          </a:prstGeom>
+          <a:solidFill>
+            <a:srgbClr val="5FA8A0"/>
+          </a:solidFill>
+          <a:ln>
+            <a:noFill/>
+          </a:ln>
+        </p:spPr>
+        <p:style>
+          <a:lnRef idx="1">
+            <a:schemeClr val="accent1"/>
+          </a:lnRef>
+          <a:fillRef idx="3">
+            <a:schemeClr val="accent1"/>
+          </a:fillRef>
+          <a:effectRef idx="2">
+            <a:schemeClr val="accent1"/>
+          </a:effectRef>
+          <a:fontRef idx="minor">
+            <a:schemeClr val="lt1"/>
+          </a:fontRef>
+        </p:style>
+        <p:txBody>
+          <a:bodyPr rtlCol="0" anchor="ctr"/>
+          <a:lstStyle/>
+          <a:p>
+            <a:pPr algn="ctr"/>
+          </a:p>
+        </p:txBody>
+      </p:sp>
+      <p:sp>
+        <p:nvSpPr>
+          <p:cNvPr id="14" name="Rectangle 13"/>
+          <p:cNvSpPr/>
+          <p:nvPr/>
+        </p:nvSpPr>
+        <p:spPr>
+          <a:xfrm>
+            <a:off x="3429000" y="1040587"/>
+            <a:ext cx="214884" cy="20116"/>
+          </a:xfrm>
+          <a:prstGeom prst="rect">
+            <a:avLst/>
+          </a:prstGeom>
+          <a:solidFill>
+            <a:srgbClr val="5FA8A0"/>
+          </a:solidFill>
+          <a:ln>
+            <a:noFill/>
+          </a:ln>
+        </p:spPr>
+        <p:style>
+          <a:lnRef idx="1">
+            <a:schemeClr val="accent1"/>
+          </a:lnRef>
+          <a:fillRef idx="3">
+            <a:schemeClr val="accent1"/>
+          </a:fillRef>
+          <a:effectRef idx="2">
+            <a:schemeClr val="accent1"/>
+          </a:effectRef>
+          <a:fontRef idx="minor">
+            <a:schemeClr val="lt1"/>
+          </a:fontRef>
+        </p:style>
+        <p:txBody>
+          <a:bodyPr rtlCol="0" anchor="ctr"/>
+          <a:lstStyle/>
+          <a:p>
+            <a:pPr algn="ctr"/>
+          </a:p>
+        </p:txBody>
+      </p:sp>
+      <p:sp>
+        <p:nvSpPr>
+          <p:cNvPr id="15" name="Rectangle 14"/>
+          <p:cNvSpPr/>
+          <p:nvPr/>
+        </p:nvSpPr>
+        <p:spPr>
+          <a:xfrm>
+            <a:off x="3630168" y="656539"/>
+            <a:ext cx="86867" cy="20116"/>
+          </a:xfrm>
+          <a:prstGeom prst="rect">
+            <a:avLst/>
+          </a:prstGeom>
+          <a:solidFill>
+            <a:srgbClr val="5FA8A0"/>
+          </a:solidFill>
+          <a:ln>
+            <a:noFill/>
+          </a:ln>
+        </p:spPr>
+        <p:style>
+          <a:lnRef idx="1">
+            <a:schemeClr val="accent1"/>
+          </a:lnRef>
+          <a:fillRef idx="3">
+            <a:schemeClr val="accent1"/>
+          </a:fillRef>
+          <a:effectRef idx="2">
+            <a:schemeClr val="accent1"/>
+          </a:effectRef>
+          <a:fontRef idx="minor">
+            <a:schemeClr val="lt1"/>
+          </a:fontRef>
+        </p:style>
+        <p:txBody>
+          <a:bodyPr rtlCol="0" anchor="ctr"/>
+          <a:lstStyle/>
+          <a:p>
+            <a:pPr algn="ctr"/>
+          </a:p>
+        </p:txBody>
+      </p:sp>
+      <p:sp>
+        <p:nvSpPr>
+          <p:cNvPr id="16" name="Rounded Rectangle 15"/>
+          <p:cNvSpPr/>
+          <p:nvPr/>
+        </p:nvSpPr>
+        <p:spPr>
+          <a:xfrm>
+            <a:off x="3703320" y="502919"/>
+            <a:ext cx="2194560" cy="329184"/>
+          </a:xfrm>
+          <a:prstGeom prst="roundRect">
+            <a:avLst/>
+          </a:prstGeom>
+          <a:solidFill>
+            <a:srgbClr val="EDF2F7"/>
+          </a:solidFill>
+          <a:ln w="9525">
+            <a:solidFill>
+              <a:srgbClr val="5FA8A0"/>
+            </a:solidFill>
+          </a:ln>
+        </p:spPr>
+        <p:style>
+          <a:lnRef idx="1">
+            <a:schemeClr val="accent1"/>
+          </a:lnRef>
+          <a:fillRef idx="3">
+            <a:schemeClr val="accent1"/>
+          </a:fillRef>
+          <a:effectRef idx="2">
+            <a:schemeClr val="accent1"/>
+          </a:effectRef>
+          <a:fontRef idx="minor">
+            <a:schemeClr val="lt1"/>
+          </a:fontRef>
+        </p:style>
+        <p:txBody>
+          <a:bodyPr rtlCol="0" anchor="ctr"/>
+          <a:lstStyle/>
+          <a:p>
+            <a:pPr algn="ctr"/>
+          </a:p>
+        </p:txBody>
+      </p:sp>
+      <p:sp>
+        <p:nvSpPr>
+          <p:cNvPr id="17" name="TextBox 16"/>
+          <p:cNvSpPr txBox="1"/>
+          <p:nvPr/>
+        </p:nvSpPr>
+        <p:spPr>
+          <a:xfrm>
+            <a:off x="3794759" y="539495"/>
+            <a:ext cx="2011679" cy="256031"/>
+          </a:xfrm>
+          <a:prstGeom prst="rect">
+            <a:avLst/>
+          </a:prstGeom>
+          <a:noFill/>
+        </p:spPr>
+        <p:txBody>
+          <a:bodyPr wrap="square">
+            <a:spAutoFit/>
+          </a:bodyPr>
+          <a:lstStyle/>
+          <a:p>
+            <a:pPr algn="l"/>
+            <a:r>
+              <a:rPr sz="800" b="0" i="0">
+                <a:solidFill>
+                  <a:srgbClr val="1A1A1A"/>
+                </a:solidFill>
+                <a:latin typeface="Segoe UI"/>
+              </a:rPr>
+              <a:t>Bio &amp; Origin Story</a:t>
+            </a:r>
+          </a:p>
+        </p:txBody>
+      </p:sp>
+      <p:sp>
+        <p:nvSpPr>
+          <p:cNvPr id="18" name="Rectangle 17"/>
+          <p:cNvSpPr/>
+          <p:nvPr/>
+        </p:nvSpPr>
+        <p:spPr>
+          <a:xfrm>
+            <a:off x="3630168" y="1040587"/>
+            <a:ext cx="86867" cy="20116"/>
+          </a:xfrm>
+          <a:prstGeom prst="rect">
+            <a:avLst/>
+          </a:prstGeom>
+          <a:solidFill>
+            <a:srgbClr val="5FA8A0"/>
+          </a:solidFill>
+          <a:ln>
+            <a:noFill/>
+          </a:ln>
+        </p:spPr>
+        <p:style>
+          <a:lnRef idx="1">
+            <a:schemeClr val="accent1"/>
+          </a:lnRef>
+          <a:fillRef idx="3">
+            <a:schemeClr val="accent1"/>
+          </a:fillRef>
+          <a:effectRef idx="2">
+            <a:schemeClr val="accent1"/>
+          </a:effectRef>
+          <a:fontRef idx="minor">
+            <a:schemeClr val="lt1"/>
+          </a:fontRef>
+        </p:style>
+        <p:txBody>
+          <a:bodyPr rtlCol="0" anchor="ctr"/>
+          <a:lstStyle/>
+          <a:p>
+            <a:pPr algn="ctr"/>
+          </a:p>
+        </p:txBody>
+      </p:sp>
+      <p:sp>
+        <p:nvSpPr>
+          <p:cNvPr id="19" name="Rounded Rectangle 18"/>
+          <p:cNvSpPr/>
+          <p:nvPr/>
+        </p:nvSpPr>
+        <p:spPr>
+          <a:xfrm>
+            <a:off x="3703320" y="886967"/>
+            <a:ext cx="2194560" cy="329184"/>
+          </a:xfrm>
+          <a:prstGeom prst="roundRect">
+            <a:avLst/>
+          </a:prstGeom>
+          <a:solidFill>
+            <a:srgbClr val="EDF2F7"/>
+          </a:solidFill>
+          <a:ln w="9525">
+            <a:solidFill>
+              <a:srgbClr val="5FA8A0"/>
+            </a:solidFill>
+          </a:ln>
+        </p:spPr>
+        <p:style>
+          <a:lnRef idx="1">
+            <a:schemeClr val="accent1"/>
+          </a:lnRef>
+          <a:fillRef idx="3">
+            <a:schemeClr val="accent1"/>
+          </a:fillRef>
+          <a:effectRef idx="2">
+            <a:schemeClr val="accent1"/>
+          </a:effectRef>
+          <a:fontRef idx="minor">
+            <a:schemeClr val="lt1"/>
+          </a:fontRef>
+        </p:style>
+        <p:txBody>
+          <a:bodyPr rtlCol="0" anchor="ctr"/>
+          <a:lstStyle/>
+          <a:p>
+            <a:pPr algn="ctr"/>
+          </a:p>
+        </p:txBody>
+      </p:sp>
+      <p:sp>
+        <p:nvSpPr>
+          <p:cNvPr id="20" name="TextBox 19"/>
+          <p:cNvSpPr txBox="1"/>
+          <p:nvPr/>
+        </p:nvSpPr>
+        <p:spPr>
+          <a:xfrm>
+            <a:off x="3794759" y="923543"/>
+            <a:ext cx="2011679" cy="256031"/>
+          </a:xfrm>
+          <a:prstGeom prst="rect">
+            <a:avLst/>
+          </a:prstGeom>
+          <a:noFill/>
+        </p:spPr>
+        <p:txBody>
+          <a:bodyPr wrap="square">
+            <a:spAutoFit/>
+          </a:bodyPr>
+          <a:lstStyle/>
+          <a:p>
+            <a:pPr algn="l"/>
+            <a:r>
+              <a:rPr sz="800" b="0" i="0">
+                <a:solidFill>
+                  <a:srgbClr val="1A1A1A"/>
+                </a:solidFill>
+                <a:latin typeface="Segoe UI"/>
+              </a:rPr>
+              <a:t>Genre &amp; Influences</a:t>
+            </a:r>
+          </a:p>
+        </p:txBody>
+      </p:sp>
+      <p:sp>
+        <p:nvSpPr>
+          <p:cNvPr id="21" name="Rectangle 20"/>
+          <p:cNvSpPr/>
+          <p:nvPr/>
+        </p:nvSpPr>
+        <p:spPr>
+          <a:xfrm>
+            <a:off x="3630168" y="1424635"/>
+            <a:ext cx="86867" cy="20116"/>
+          </a:xfrm>
+          <a:prstGeom prst="rect">
+            <a:avLst/>
+          </a:prstGeom>
+          <a:solidFill>
+            <a:srgbClr val="5FA8A0"/>
+          </a:solidFill>
+          <a:ln>
+            <a:noFill/>
+          </a:ln>
+        </p:spPr>
+        <p:style>
+          <a:lnRef idx="1">
+            <a:schemeClr val="accent1"/>
+          </a:lnRef>
+          <a:fillRef idx="3">
+            <a:schemeClr val="accent1"/>
+          </a:fillRef>
+          <a:effectRef idx="2">
+            <a:schemeClr val="accent1"/>
+          </a:effectRef>
+          <a:fontRef idx="minor">
+            <a:schemeClr val="lt1"/>
+          </a:fontRef>
+        </p:style>
+        <p:txBody>
+          <a:bodyPr rtlCol="0" anchor="ctr"/>
+          <a:lstStyle/>
+          <a:p>
+            <a:pPr algn="ctr"/>
+          </a:p>
+        </p:txBody>
+      </p:sp>
+      <p:sp>
+        <p:nvSpPr>
+          <p:cNvPr id="22" name="Rounded Rectangle 21"/>
+          <p:cNvSpPr/>
+          <p:nvPr/>
+        </p:nvSpPr>
+        <p:spPr>
+          <a:xfrm>
+            <a:off x="3703320" y="1271016"/>
+            <a:ext cx="2194560" cy="329184"/>
+          </a:xfrm>
+          <a:prstGeom prst="roundRect">
+            <a:avLst/>
+          </a:prstGeom>
+          <a:solidFill>
+            <a:srgbClr val="EDF2F7"/>
+          </a:solidFill>
+          <a:ln w="9525">
+            <a:solidFill>
+              <a:srgbClr val="5FA8A0"/>
+            </a:solidFill>
+          </a:ln>
+        </p:spPr>
+        <p:style>
+          <a:lnRef idx="1">
+            <a:schemeClr val="accent1"/>
+          </a:lnRef>
+          <a:fillRef idx="3">
+            <a:schemeClr val="accent1"/>
+          </a:fillRef>
+          <a:effectRef idx="2">
+            <a:schemeClr val="accent1"/>
+          </a:effectRef>
+          <a:fontRef idx="minor">
+            <a:schemeClr val="lt1"/>
+          </a:fontRef>
+        </p:style>
+        <p:txBody>
+          <a:bodyPr rtlCol="0" anchor="ctr"/>
+          <a:lstStyle/>
+          <a:p>
+            <a:pPr algn="ctr"/>
+          </a:p>
+        </p:txBody>
+      </p:sp>
+      <p:sp>
+        <p:nvSpPr>
+          <p:cNvPr id="23" name="TextBox 22"/>
+          <p:cNvSpPr txBox="1"/>
+          <p:nvPr/>
+        </p:nvSpPr>
+        <p:spPr>
+          <a:xfrm>
+            <a:off x="3794759" y="1307592"/>
+            <a:ext cx="2011679" cy="256031"/>
+          </a:xfrm>
+          <a:prstGeom prst="rect">
+            <a:avLst/>
+          </a:prstGeom>
+          <a:noFill/>
+        </p:spPr>
+        <p:txBody>
+          <a:bodyPr wrap="square">
+            <a:spAutoFit/>
+          </a:bodyPr>
+          <a:lstStyle/>
+          <a:p>
+            <a:pPr algn="l"/>
+            <a:r>
+              <a:rPr sz="800" b="0" i="0">
+                <a:solidFill>
+                  <a:srgbClr val="1A1A1A"/>
+                </a:solidFill>
+                <a:latin typeface="Segoe UI"/>
+              </a:rPr>
+              <a:t>Band Member Info</a:t>
+            </a:r>
+          </a:p>
+        </p:txBody>
+      </p:sp>
+      <p:sp>
+        <p:nvSpPr>
+          <p:cNvPr id="24" name="Rectangle 23"/>
+          <p:cNvSpPr/>
+          <p:nvPr/>
+        </p:nvSpPr>
+        <p:spPr>
+          <a:xfrm>
+            <a:off x="1892807" y="2247595"/>
+            <a:ext cx="86868" cy="20116"/>
+          </a:xfrm>
+          <a:prstGeom prst="rect">
+            <a:avLst/>
+          </a:prstGeom>
+          <a:solidFill>
+            <a:srgbClr val="4A90E2"/>
+          </a:solidFill>
+          <a:ln>
+            <a:noFill/>
+          </a:ln>
+        </p:spPr>
+        <p:style>
+          <a:lnRef idx="1">
+            <a:schemeClr val="accent1"/>
+          </a:lnRef>
+          <a:fillRef idx="3">
+            <a:schemeClr val="accent1"/>
+          </a:fillRef>
+          <a:effectRef idx="2">
+            <a:schemeClr val="accent1"/>
+          </a:effectRef>
+          <a:fontRef idx="minor">
+            <a:schemeClr val="lt1"/>
+          </a:fontRef>
+        </p:style>
+        <p:txBody>
+          <a:bodyPr rtlCol="0" anchor="ctr"/>
+          <a:lstStyle/>
+          <a:p>
+            <a:pPr algn="ctr"/>
+          </a:p>
+        </p:txBody>
+      </p:sp>
+      <p:sp>
+        <p:nvSpPr>
+          <p:cNvPr id="25" name="Rounded Rectangle 24"/>
+          <p:cNvSpPr/>
+          <p:nvPr/>
+        </p:nvSpPr>
+        <p:spPr>
+          <a:xfrm>
+            <a:off x="1965960" y="2066544"/>
+            <a:ext cx="1463040" cy="384048"/>
+          </a:xfrm>
+          <a:prstGeom prst="roundRect">
+            <a:avLst/>
+          </a:prstGeom>
+          <a:solidFill>
+            <a:srgbClr val="4A90E2"/>
+          </a:solidFill>
+          <a:ln w="12700">
+            <a:solidFill>
+              <a:srgbClr val="4A90E2"/>
+            </a:solidFill>
+          </a:ln>
+        </p:spPr>
+        <p:style>
+          <a:lnRef idx="1">
+            <a:schemeClr val="accent1"/>
+          </a:lnRef>
+          <a:fillRef idx="3">
+            <a:schemeClr val="accent1"/>
+          </a:fillRef>
+          <a:effectRef idx="2">
+            <a:schemeClr val="accent1"/>
+          </a:effectRef>
+          <a:fontRef idx="minor">
+            <a:schemeClr val="lt1"/>
+          </a:fontRef>
+        </p:style>
+        <p:txBody>
+          <a:bodyPr rtlCol="0" anchor="ctr"/>
+          <a:lstStyle/>
+          <a:p>
+            <a:pPr algn="ctr"/>
+          </a:p>
+        </p:txBody>
+      </p:sp>
+      <p:sp>
+        <p:nvSpPr>
+          <p:cNvPr id="26" name="TextBox 25"/>
+          <p:cNvSpPr txBox="1"/>
+          <p:nvPr/>
+        </p:nvSpPr>
+        <p:spPr>
+          <a:xfrm>
+            <a:off x="1965960" y="2066544"/>
+            <a:ext cx="1463040" cy="384048"/>
+          </a:xfrm>
+          <a:prstGeom prst="rect">
+            <a:avLst/>
+          </a:prstGeom>
+          <a:noFill/>
+        </p:spPr>
+        <p:txBody>
+          <a:bodyPr wrap="square">
+            <a:spAutoFit/>
+          </a:bodyPr>
+          <a:lstStyle/>
+          <a:p>
+            <a:pPr algn="ctr"/>
+            <a:r>
+              <a:rPr sz="900" b="1" i="0">
+                <a:solidFill>
+                  <a:srgbClr val="FFFFFF"/>
+                </a:solidFill>
+                <a:latin typeface="Segoe UI"/>
+              </a:rPr>
+              <a:t>Music</a:t>
+            </a:r>
+          </a:p>
+        </p:txBody>
+      </p:sp>
+      <p:sp>
+        <p:nvSpPr>
+          <p:cNvPr id="27" name="Rectangle 26"/>
+          <p:cNvSpPr/>
+          <p:nvPr/>
+        </p:nvSpPr>
+        <p:spPr>
+          <a:xfrm>
+            <a:off x="3619195" y="1874520"/>
+            <a:ext cx="20116" cy="781811"/>
+          </a:xfrm>
+          <a:prstGeom prst="rect">
+            <a:avLst/>
+          </a:prstGeom>
+          <a:solidFill>
+            <a:srgbClr val="4A90E2"/>
+          </a:solidFill>
+          <a:ln>
+            <a:noFill/>
+          </a:ln>
+        </p:spPr>
+        <p:style>
+          <a:lnRef idx="1">
+            <a:schemeClr val="accent1"/>
+          </a:lnRef>
+          <a:fillRef idx="3">
+            <a:schemeClr val="accent1"/>
+          </a:fillRef>
+          <a:effectRef idx="2">
+            <a:schemeClr val="accent1"/>
+          </a:effectRef>
+          <a:fontRef idx="minor">
+            <a:schemeClr val="lt1"/>
+          </a:fontRef>
+        </p:style>
+        <p:txBody>
+          <a:bodyPr rtlCol="0" anchor="ctr"/>
+          <a:lstStyle/>
+          <a:p>
+            <a:pPr algn="ctr"/>
+          </a:p>
+        </p:txBody>
+      </p:sp>
+      <p:sp>
+        <p:nvSpPr>
+          <p:cNvPr id="28" name="Rectangle 27"/>
+          <p:cNvSpPr/>
+          <p:nvPr/>
+        </p:nvSpPr>
+        <p:spPr>
+          <a:xfrm>
+            <a:off x="3429000" y="2247595"/>
+            <a:ext cx="214884" cy="20116"/>
+          </a:xfrm>
+          <a:prstGeom prst="rect">
+            <a:avLst/>
+          </a:prstGeom>
+          <a:solidFill>
+            <a:srgbClr val="4A90E2"/>
+          </a:solidFill>
+          <a:ln>
+            <a:noFill/>
+          </a:ln>
+        </p:spPr>
+        <p:style>
+          <a:lnRef idx="1">
+            <a:schemeClr val="accent1"/>
+          </a:lnRef>
+          <a:fillRef idx="3">
+            <a:schemeClr val="accent1"/>
+          </a:fillRef>
+          <a:effectRef idx="2">
+            <a:schemeClr val="accent1"/>
+          </a:effectRef>
+          <a:fontRef idx="minor">
+            <a:schemeClr val="lt1"/>
+          </a:fontRef>
+        </p:style>
+        <p:txBody>
+          <a:bodyPr rtlCol="0" anchor="ctr"/>
+          <a:lstStyle/>
+          <a:p>
+            <a:pPr algn="ctr"/>
+          </a:p>
+        </p:txBody>
+      </p:sp>
+      <p:sp>
+        <p:nvSpPr>
+          <p:cNvPr id="29" name="Rectangle 28"/>
+          <p:cNvSpPr/>
+          <p:nvPr/>
+        </p:nvSpPr>
+        <p:spPr>
+          <a:xfrm>
+            <a:off x="3630168" y="1863547"/>
+            <a:ext cx="86867" cy="20116"/>
+          </a:xfrm>
+          <a:prstGeom prst="rect">
+            <a:avLst/>
+          </a:prstGeom>
+          <a:solidFill>
+            <a:srgbClr val="4A90E2"/>
+          </a:solidFill>
+          <a:ln>
+            <a:noFill/>
+          </a:ln>
+        </p:spPr>
+        <p:style>
+          <a:lnRef idx="1">
+            <a:schemeClr val="accent1"/>
+          </a:lnRef>
+          <a:fillRef idx="3">
+            <a:schemeClr val="accent1"/>
+          </a:fillRef>
+          <a:effectRef idx="2">
+            <a:schemeClr val="accent1"/>
+          </a:effectRef>
+          <a:fontRef idx="minor">
+            <a:schemeClr val="lt1"/>
+          </a:fontRef>
+        </p:style>
+        <p:txBody>
+          <a:bodyPr rtlCol="0" anchor="ctr"/>
+          <a:lstStyle/>
+          <a:p>
+            <a:pPr algn="ctr"/>
+          </a:p>
+        </p:txBody>
+      </p:sp>
+      <p:sp>
+        <p:nvSpPr>
+          <p:cNvPr id="30" name="Rounded Rectangle 29"/>
+          <p:cNvSpPr/>
+          <p:nvPr/>
+        </p:nvSpPr>
+        <p:spPr>
+          <a:xfrm>
+            <a:off x="3703320" y="1709928"/>
+            <a:ext cx="2194560" cy="329184"/>
+          </a:xfrm>
+          <a:prstGeom prst="roundRect">
+            <a:avLst/>
+          </a:prstGeom>
+          <a:solidFill>
+            <a:srgbClr val="EDF2F7"/>
+          </a:solidFill>
+          <a:ln w="9525">
+            <a:solidFill>
+              <a:srgbClr val="4A90E2"/>
+            </a:solidFill>
+          </a:ln>
+        </p:spPr>
+        <p:style>
+          <a:lnRef idx="1">
+            <a:schemeClr val="accent1"/>
+          </a:lnRef>
+          <a:fillRef idx="3">
+            <a:schemeClr val="accent1"/>
+          </a:fillRef>
+          <a:effectRef idx="2">
+            <a:schemeClr val="accent1"/>
+          </a:effectRef>
+          <a:fontRef idx="minor">
+            <a:schemeClr val="lt1"/>
+          </a:fontRef>
+        </p:style>
+        <p:txBody>
+          <a:bodyPr rtlCol="0" anchor="ctr"/>
+          <a:lstStyle/>
+          <a:p>
+            <a:pPr algn="ctr"/>
+          </a:p>
+        </p:txBody>
+      </p:sp>
+      <p:sp>
+        <p:nvSpPr>
+          <p:cNvPr id="31" name="TextBox 30"/>
+          <p:cNvSpPr txBox="1"/>
+          <p:nvPr/>
+        </p:nvSpPr>
+        <p:spPr>
+          <a:xfrm>
+            <a:off x="3794759" y="1746504"/>
+            <a:ext cx="2011679" cy="256031"/>
+          </a:xfrm>
+          <a:prstGeom prst="rect">
+            <a:avLst/>
+          </a:prstGeom>
+          <a:noFill/>
+        </p:spPr>
+        <p:txBody>
+          <a:bodyPr wrap="square">
+            <a:spAutoFit/>
+          </a:bodyPr>
+          <a:lstStyle/>
+          <a:p>
+            <a:pPr algn="l"/>
+            <a:r>
+              <a:rPr sz="800" b="0" i="0">
+                <a:solidFill>
+                  <a:srgbClr val="1A1A1A"/>
+                </a:solidFill>
+                <a:latin typeface="Segoe UI"/>
+              </a:rPr>
+              <a:t>Spotify Tracks</a:t>
+            </a:r>
+          </a:p>
+        </p:txBody>
+      </p:sp>
+      <p:sp>
+        <p:nvSpPr>
+          <p:cNvPr id="32" name="Rectangle 31"/>
+          <p:cNvSpPr/>
+          <p:nvPr/>
+        </p:nvSpPr>
+        <p:spPr>
+          <a:xfrm>
+            <a:off x="6088075" y="1682496"/>
+            <a:ext cx="20116" cy="397764"/>
+          </a:xfrm>
+          <a:prstGeom prst="rect">
+            <a:avLst/>
+          </a:prstGeom>
+          <a:solidFill>
+            <a:srgbClr val="4A90E2"/>
+          </a:solidFill>
+          <a:ln>
+            <a:noFill/>
+          </a:ln>
+        </p:spPr>
+        <p:style>
+          <a:lnRef idx="1">
+            <a:schemeClr val="accent1"/>
+          </a:lnRef>
+          <a:fillRef idx="3">
+            <a:schemeClr val="accent1"/>
+          </a:fillRef>
+          <a:effectRef idx="2">
+            <a:schemeClr val="accent1"/>
+          </a:effectRef>
+          <a:fontRef idx="minor">
+            <a:schemeClr val="lt1"/>
+          </a:fontRef>
+        </p:style>
+        <p:txBody>
+          <a:bodyPr rtlCol="0" anchor="ctr"/>
+          <a:lstStyle/>
+          <a:p>
+            <a:pPr algn="ctr"/>
+          </a:p>
+        </p:txBody>
+      </p:sp>
+      <p:sp>
+        <p:nvSpPr>
+          <p:cNvPr id="33" name="Rectangle 32"/>
+          <p:cNvSpPr/>
+          <p:nvPr/>
+        </p:nvSpPr>
+        <p:spPr>
+          <a:xfrm>
+            <a:off x="5897879" y="1863547"/>
+            <a:ext cx="214884" cy="20116"/>
+          </a:xfrm>
+          <a:prstGeom prst="rect">
+            <a:avLst/>
+          </a:prstGeom>
+          <a:solidFill>
+            <a:srgbClr val="4A90E2"/>
+          </a:solidFill>
+          <a:ln>
+            <a:noFill/>
+          </a:ln>
+        </p:spPr>
+        <p:style>
+          <a:lnRef idx="1">
+            <a:schemeClr val="accent1"/>
+          </a:lnRef>
+          <a:fillRef idx="3">
+            <a:schemeClr val="accent1"/>
+          </a:fillRef>
+          <a:effectRef idx="2">
+            <a:schemeClr val="accent1"/>
+          </a:effectRef>
+          <a:fontRef idx="minor">
+            <a:schemeClr val="lt1"/>
+          </a:fontRef>
+        </p:style>
+        <p:txBody>
+          <a:bodyPr rtlCol="0" anchor="ctr"/>
+          <a:lstStyle/>
+          <a:p>
+            <a:pPr algn="ctr"/>
+          </a:p>
+        </p:txBody>
+      </p:sp>
+      <p:sp>
+        <p:nvSpPr>
+          <p:cNvPr id="34" name="Rectangle 33"/>
+          <p:cNvSpPr/>
+          <p:nvPr/>
+        </p:nvSpPr>
+        <p:spPr>
+          <a:xfrm>
+            <a:off x="6099048" y="1671523"/>
+            <a:ext cx="86868" cy="20116"/>
+          </a:xfrm>
+          <a:prstGeom prst="rect">
+            <a:avLst/>
+          </a:prstGeom>
+          <a:solidFill>
+            <a:srgbClr val="4A90E2"/>
+          </a:solidFill>
+          <a:ln>
+            <a:noFill/>
+          </a:ln>
+        </p:spPr>
+        <p:style>
+          <a:lnRef idx="1">
+            <a:schemeClr val="accent1"/>
+          </a:lnRef>
+          <a:fillRef idx="3">
+            <a:schemeClr val="accent1"/>
+          </a:fillRef>
+          <a:effectRef idx="2">
+            <a:schemeClr val="accent1"/>
+          </a:effectRef>
+          <a:fontRef idx="minor">
+            <a:schemeClr val="lt1"/>
+          </a:fontRef>
+        </p:style>
+        <p:txBody>
+          <a:bodyPr rtlCol="0" anchor="ctr"/>
+          <a:lstStyle/>
+          <a:p>
+            <a:pPr algn="ctr"/>
+          </a:p>
+        </p:txBody>
+      </p:sp>
+      <p:sp>
+        <p:nvSpPr>
+          <p:cNvPr id="35" name="Rounded Rectangle 34"/>
+          <p:cNvSpPr/>
+          <p:nvPr/>
+        </p:nvSpPr>
+        <p:spPr>
+          <a:xfrm>
+            <a:off x="6172200" y="1517904"/>
+            <a:ext cx="2011680" cy="329184"/>
+          </a:xfrm>
+          <a:prstGeom prst="roundRect">
+            <a:avLst/>
+          </a:prstGeom>
+          <a:solidFill>
+            <a:srgbClr val="F5F8FC"/>
+          </a:solidFill>
+          <a:ln w="9525">
+            <a:solidFill>
+              <a:srgbClr val="4A90E2"/>
+            </a:solidFill>
+          </a:ln>
+        </p:spPr>
+        <p:style>
+          <a:lnRef idx="1">
+            <a:schemeClr val="accent1"/>
+          </a:lnRef>
+          <a:fillRef idx="3">
+            <a:schemeClr val="accent1"/>
+          </a:fillRef>
+          <a:effectRef idx="2">
+            <a:schemeClr val="accent1"/>
+          </a:effectRef>
+          <a:fontRef idx="minor">
+            <a:schemeClr val="lt1"/>
+          </a:fontRef>
+        </p:style>
+        <p:txBody>
+          <a:bodyPr rtlCol="0" anchor="ctr"/>
+          <a:lstStyle/>
+          <a:p>
+            <a:pPr algn="ctr"/>
+          </a:p>
+        </p:txBody>
+      </p:sp>
+      <p:sp>
+        <p:nvSpPr>
+          <p:cNvPr id="36" name="TextBox 35"/>
+          <p:cNvSpPr txBox="1"/>
+          <p:nvPr/>
+        </p:nvSpPr>
+        <p:spPr>
+          <a:xfrm>
+            <a:off x="6263640" y="1554480"/>
+            <a:ext cx="1828800" cy="256031"/>
+          </a:xfrm>
+          <a:prstGeom prst="rect">
+            <a:avLst/>
+          </a:prstGeom>
+          <a:noFill/>
+        </p:spPr>
+        <p:txBody>
+          <a:bodyPr wrap="square">
+            <a:spAutoFit/>
+          </a:bodyPr>
+          <a:lstStyle/>
+          <a:p>
+            <a:pPr algn="l"/>
+            <a:r>
+              <a:rPr sz="800" b="0" i="0">
+                <a:solidFill>
+                  <a:srgbClr val="6B7280"/>
+                </a:solidFill>
+                <a:latin typeface="Segoe UI"/>
+              </a:rPr>
+              <a:t>Song Playlist</a:t>
+            </a:r>
+          </a:p>
+        </p:txBody>
+      </p:sp>
+      <p:sp>
+        <p:nvSpPr>
+          <p:cNvPr id="37" name="Rectangle 36"/>
+          <p:cNvSpPr/>
+          <p:nvPr/>
+        </p:nvSpPr>
+        <p:spPr>
+          <a:xfrm>
+            <a:off x="6099048" y="2055571"/>
+            <a:ext cx="86868" cy="20116"/>
+          </a:xfrm>
+          <a:prstGeom prst="rect">
+            <a:avLst/>
+          </a:prstGeom>
+          <a:solidFill>
+            <a:srgbClr val="4A90E2"/>
+          </a:solidFill>
+          <a:ln>
+            <a:noFill/>
+          </a:ln>
+        </p:spPr>
+        <p:style>
+          <a:lnRef idx="1">
+            <a:schemeClr val="accent1"/>
+          </a:lnRef>
+          <a:fillRef idx="3">
+            <a:schemeClr val="accent1"/>
+          </a:fillRef>
+          <a:effectRef idx="2">
+            <a:schemeClr val="accent1"/>
+          </a:effectRef>
+          <a:fontRef idx="minor">
+            <a:schemeClr val="lt1"/>
+          </a:fontRef>
+        </p:style>
+        <p:txBody>
+          <a:bodyPr rtlCol="0" anchor="ctr"/>
+          <a:lstStyle/>
+          <a:p>
+            <a:pPr algn="ctr"/>
+          </a:p>
+        </p:txBody>
+      </p:sp>
+      <p:sp>
+        <p:nvSpPr>
+          <p:cNvPr id="38" name="Rounded Rectangle 37"/>
+          <p:cNvSpPr/>
+          <p:nvPr/>
+        </p:nvSpPr>
+        <p:spPr>
+          <a:xfrm>
+            <a:off x="6172200" y="1901952"/>
+            <a:ext cx="2011680" cy="329184"/>
+          </a:xfrm>
+          <a:prstGeom prst="roundRect">
+            <a:avLst/>
+          </a:prstGeom>
+          <a:solidFill>
+            <a:srgbClr val="F5F8FC"/>
+          </a:solidFill>
+          <a:ln w="9525">
+            <a:solidFill>
+              <a:srgbClr val="4A90E2"/>
+            </a:solidFill>
+          </a:ln>
+        </p:spPr>
+        <p:style>
+          <a:lnRef idx="1">
+            <a:schemeClr val="accent1"/>
+          </a:lnRef>
+          <a:fillRef idx="3">
+            <a:schemeClr val="accent1"/>
+          </a:fillRef>
+          <a:effectRef idx="2">
+            <a:schemeClr val="accent1"/>
+          </a:effectRef>
+          <a:fontRef idx="minor">
+            <a:schemeClr val="lt1"/>
+          </a:fontRef>
+        </p:style>
+        <p:txBody>
+          <a:bodyPr rtlCol="0" anchor="ctr"/>
+          <a:lstStyle/>
+          <a:p>
+            <a:pPr algn="ctr"/>
+          </a:p>
+        </p:txBody>
+      </p:sp>
+      <p:sp>
+        <p:nvSpPr>
+          <p:cNvPr id="39" name="TextBox 38"/>
+          <p:cNvSpPr txBox="1"/>
+          <p:nvPr/>
+        </p:nvSpPr>
+        <p:spPr>
+          <a:xfrm>
+            <a:off x="6263640" y="1938528"/>
+            <a:ext cx="1828800" cy="256031"/>
+          </a:xfrm>
+          <a:prstGeom prst="rect">
+            <a:avLst/>
+          </a:prstGeom>
+          <a:noFill/>
+        </p:spPr>
+        <p:txBody>
+          <a:bodyPr wrap="square">
+            <a:spAutoFit/>
+          </a:bodyPr>
+          <a:lstStyle/>
+          <a:p>
+            <a:pPr algn="l"/>
+            <a:r>
+              <a:rPr sz="800" b="0" i="0">
+                <a:solidFill>
+                  <a:srgbClr val="6B7280"/>
+                </a:solidFill>
+                <a:latin typeface="Segoe UI"/>
+              </a:rPr>
+              <a:t>Embed Player</a:t>
+            </a:r>
+          </a:p>
+        </p:txBody>
+      </p:sp>
+      <p:sp>
+        <p:nvSpPr>
+          <p:cNvPr id="40" name="Rectangle 39"/>
+          <p:cNvSpPr/>
+          <p:nvPr/>
+        </p:nvSpPr>
+        <p:spPr>
+          <a:xfrm>
+            <a:off x="3630168" y="2247595"/>
+            <a:ext cx="86867" cy="20116"/>
+          </a:xfrm>
+          <a:prstGeom prst="rect">
+            <a:avLst/>
+          </a:prstGeom>
+          <a:solidFill>
+            <a:srgbClr val="4A90E2"/>
+          </a:solidFill>
+          <a:ln>
+            <a:noFill/>
+          </a:ln>
+        </p:spPr>
+        <p:style>
+          <a:lnRef idx="1">
+            <a:schemeClr val="accent1"/>
+          </a:lnRef>
+          <a:fillRef idx="3">
+            <a:schemeClr val="accent1"/>
+          </a:fillRef>
+          <a:effectRef idx="2">
+            <a:schemeClr val="accent1"/>
+          </a:effectRef>
+          <a:fontRef idx="minor">
+            <a:schemeClr val="lt1"/>
+          </a:fontRef>
+        </p:style>
+        <p:txBody>
+          <a:bodyPr rtlCol="0" anchor="ctr"/>
+          <a:lstStyle/>
+          <a:p>
+            <a:pPr algn="ctr"/>
+          </a:p>
+        </p:txBody>
+      </p:sp>
+      <p:sp>
+        <p:nvSpPr>
+          <p:cNvPr id="41" name="Rounded Rectangle 40"/>
+          <p:cNvSpPr/>
+          <p:nvPr/>
+        </p:nvSpPr>
+        <p:spPr>
+          <a:xfrm>
+            <a:off x="3703320" y="2093976"/>
+            <a:ext cx="2194560" cy="329184"/>
+          </a:xfrm>
+          <a:prstGeom prst="roundRect">
+            <a:avLst/>
+          </a:prstGeom>
+          <a:solidFill>
+            <a:srgbClr val="EDF2F7"/>
+          </a:solidFill>
+          <a:ln w="9525">
+            <a:solidFill>
+              <a:srgbClr val="4A90E2"/>
+            </a:solidFill>
+          </a:ln>
+        </p:spPr>
+        <p:style>
+          <a:lnRef idx="1">
+            <a:schemeClr val="accent1"/>
+          </a:lnRef>
+          <a:fillRef idx="3">
+            <a:schemeClr val="accent1"/>
+          </a:fillRef>
+          <a:effectRef idx="2">
+            <a:schemeClr val="accent1"/>
+          </a:effectRef>
+          <a:fontRef idx="minor">
+            <a:schemeClr val="lt1"/>
+          </a:fontRef>
+        </p:style>
+        <p:txBody>
+          <a:bodyPr rtlCol="0" anchor="ctr"/>
+          <a:lstStyle/>
+          <a:p>
+            <a:pPr algn="ctr"/>
+          </a:p>
+        </p:txBody>
+      </p:sp>
+      <p:sp>
+        <p:nvSpPr>
+          <p:cNvPr id="42" name="TextBox 41"/>
+          <p:cNvSpPr txBox="1"/>
+          <p:nvPr/>
+        </p:nvSpPr>
+        <p:spPr>
+          <a:xfrm>
+            <a:off x="3794759" y="2130552"/>
+            <a:ext cx="2011679" cy="256031"/>
+          </a:xfrm>
+          <a:prstGeom prst="rect">
+            <a:avLst/>
+          </a:prstGeom>
+          <a:noFill/>
+        </p:spPr>
+        <p:txBody>
+          <a:bodyPr wrap="square">
+            <a:spAutoFit/>
+          </a:bodyPr>
+          <a:lstStyle/>
+          <a:p>
+            <a:pPr algn="l"/>
+            <a:r>
+              <a:rPr sz="800" b="0" i="0">
+                <a:solidFill>
+                  <a:srgbClr val="1A1A1A"/>
+                </a:solidFill>
+                <a:latin typeface="Segoe UI"/>
+              </a:rPr>
+              <a:t>Track Metadata</a:t>
+            </a:r>
+          </a:p>
+        </p:txBody>
+      </p:sp>
+      <p:sp>
+        <p:nvSpPr>
+          <p:cNvPr id="43" name="Rectangle 42"/>
+          <p:cNvSpPr/>
+          <p:nvPr/>
+        </p:nvSpPr>
+        <p:spPr>
+          <a:xfrm>
+            <a:off x="3630168" y="2631643"/>
+            <a:ext cx="86867" cy="20116"/>
+          </a:xfrm>
+          <a:prstGeom prst="rect">
+            <a:avLst/>
+          </a:prstGeom>
+          <a:solidFill>
+            <a:srgbClr val="4A90E2"/>
+          </a:solidFill>
+          <a:ln>
+            <a:noFill/>
+          </a:ln>
+        </p:spPr>
+        <p:style>
+          <a:lnRef idx="1">
+            <a:schemeClr val="accent1"/>
+          </a:lnRef>
+          <a:fillRef idx="3">
+            <a:schemeClr val="accent1"/>
+          </a:fillRef>
+          <a:effectRef idx="2">
+            <a:schemeClr val="accent1"/>
+          </a:effectRef>
+          <a:fontRef idx="minor">
+            <a:schemeClr val="lt1"/>
+          </a:fontRef>
+        </p:style>
+        <p:txBody>
+          <a:bodyPr rtlCol="0" anchor="ctr"/>
+          <a:lstStyle/>
+          <a:p>
+            <a:pPr algn="ctr"/>
+          </a:p>
+        </p:txBody>
+      </p:sp>
+      <p:sp>
+        <p:nvSpPr>
+          <p:cNvPr id="44" name="Rounded Rectangle 43"/>
+          <p:cNvSpPr/>
+          <p:nvPr/>
+        </p:nvSpPr>
+        <p:spPr>
+          <a:xfrm>
+            <a:off x="3703320" y="2478024"/>
+            <a:ext cx="2194560" cy="329184"/>
+          </a:xfrm>
+          <a:prstGeom prst="roundRect">
+            <a:avLst/>
+          </a:prstGeom>
+          <a:solidFill>
+            <a:srgbClr val="EDF2F7"/>
+          </a:solidFill>
+          <a:ln w="9525">
+            <a:solidFill>
+              <a:srgbClr val="4A90E2"/>
+            </a:solidFill>
+          </a:ln>
+        </p:spPr>
+        <p:style>
+          <a:lnRef idx="1">
+            <a:schemeClr val="accent1"/>
+          </a:lnRef>
+          <a:fillRef idx="3">
+            <a:schemeClr val="accent1"/>
+          </a:fillRef>
+          <a:effectRef idx="2">
+            <a:schemeClr val="accent1"/>
+          </a:effectRef>
+          <a:fontRef idx="minor">
+            <a:schemeClr val="lt1"/>
+          </a:fontRef>
+        </p:style>
+        <p:txBody>
+          <a:bodyPr rtlCol="0" anchor="ctr"/>
+          <a:lstStyle/>
+          <a:p>
+            <a:pPr algn="ctr"/>
+          </a:p>
+        </p:txBody>
+      </p:sp>
+      <p:sp>
+        <p:nvSpPr>
+          <p:cNvPr id="45" name="TextBox 44"/>
+          <p:cNvSpPr txBox="1"/>
+          <p:nvPr/>
+        </p:nvSpPr>
+        <p:spPr>
+          <a:xfrm>
+            <a:off x="3794759" y="2514600"/>
+            <a:ext cx="2011679" cy="256031"/>
+          </a:xfrm>
+          <a:prstGeom prst="rect">
+            <a:avLst/>
+          </a:prstGeom>
+          <a:noFill/>
+        </p:spPr>
+        <p:txBody>
+          <a:bodyPr wrap="square">
+            <a:spAutoFit/>
+          </a:bodyPr>
+          <a:lstStyle/>
+          <a:p>
+            <a:pPr algn="l"/>
+            <a:r>
+              <a:rPr sz="800" b="0" i="0">
+                <a:solidFill>
+                  <a:srgbClr val="1A1A1A"/>
+                </a:solidFill>
+                <a:latin typeface="Segoe UI"/>
+              </a:rPr>
+              <a:t>Live Footage</a:t>
+            </a:r>
+          </a:p>
+        </p:txBody>
+      </p:sp>
+      <p:sp>
+        <p:nvSpPr>
+          <p:cNvPr id="46" name="Rectangle 45"/>
+          <p:cNvSpPr/>
+          <p:nvPr/>
+        </p:nvSpPr>
+        <p:spPr>
+          <a:xfrm>
+            <a:off x="1892807" y="3454603"/>
+            <a:ext cx="86868" cy="20116"/>
+          </a:xfrm>
+          <a:prstGeom prst="rect">
+            <a:avLst/>
+          </a:prstGeom>
+          <a:solidFill>
+            <a:srgbClr val="5FA8A0"/>
+          </a:solidFill>
+          <a:ln>
+            <a:noFill/>
+          </a:ln>
+        </p:spPr>
+        <p:style>
+          <a:lnRef idx="1">
+            <a:schemeClr val="accent1"/>
+          </a:lnRef>
+          <a:fillRef idx="3">
+            <a:schemeClr val="accent1"/>
+          </a:fillRef>
+          <a:effectRef idx="2">
+            <a:schemeClr val="accent1"/>
+          </a:effectRef>
+          <a:fontRef idx="minor">
+            <a:schemeClr val="lt1"/>
+          </a:fontRef>
+        </p:style>
+        <p:txBody>
+          <a:bodyPr rtlCol="0" anchor="ctr"/>
+          <a:lstStyle/>
+          <a:p>
+            <a:pPr algn="ctr"/>
+          </a:p>
+        </p:txBody>
+      </p:sp>
+      <p:sp>
+        <p:nvSpPr>
+          <p:cNvPr id="47" name="Rounded Rectangle 46"/>
+          <p:cNvSpPr/>
+          <p:nvPr/>
+        </p:nvSpPr>
+        <p:spPr>
+          <a:xfrm>
+            <a:off x="1965960" y="3273552"/>
+            <a:ext cx="1463040" cy="384048"/>
+          </a:xfrm>
+          <a:prstGeom prst="roundRect">
+            <a:avLst/>
+          </a:prstGeom>
+          <a:solidFill>
+            <a:srgbClr val="5FA8A0"/>
+          </a:solidFill>
+          <a:ln w="12700">
+            <a:solidFill>
+              <a:srgbClr val="5FA8A0"/>
+            </a:solidFill>
+          </a:ln>
+        </p:spPr>
+        <p:style>
+          <a:lnRef idx="1">
+            <a:schemeClr val="accent1"/>
+          </a:lnRef>
+          <a:fillRef idx="3">
+            <a:schemeClr val="accent1"/>
+          </a:fillRef>
+          <a:effectRef idx="2">
+            <a:schemeClr val="accent1"/>
+          </a:effectRef>
+          <a:fontRef idx="minor">
+            <a:schemeClr val="lt1"/>
+          </a:fontRef>
+        </p:style>
+        <p:txBody>
+          <a:bodyPr rtlCol="0" anchor="ctr"/>
+          <a:lstStyle/>
+          <a:p>
+            <a:pPr algn="ctr"/>
+          </a:p>
+        </p:txBody>
+      </p:sp>
+      <p:sp>
+        <p:nvSpPr>
+          <p:cNvPr id="48" name="TextBox 47"/>
+          <p:cNvSpPr txBox="1"/>
+          <p:nvPr/>
+        </p:nvSpPr>
+        <p:spPr>
+          <a:xfrm>
+            <a:off x="1965960" y="3273552"/>
+            <a:ext cx="1463040" cy="384048"/>
+          </a:xfrm>
+          <a:prstGeom prst="rect">
+            <a:avLst/>
+          </a:prstGeom>
+          <a:noFill/>
+        </p:spPr>
+        <p:txBody>
+          <a:bodyPr wrap="square">
+            <a:spAutoFit/>
+          </a:bodyPr>
+          <a:lstStyle/>
+          <a:p>
+            <a:pPr algn="ctr"/>
+            <a:r>
+              <a:rPr sz="900" b="1" i="0">
+                <a:solidFill>
+                  <a:srgbClr val="FFFFFF"/>
+                </a:solidFill>
+                <a:latin typeface="Segoe UI"/>
+              </a:rPr>
+              <a:t>Blog</a:t>
+            </a:r>
+          </a:p>
+        </p:txBody>
+      </p:sp>
+      <p:sp>
+        <p:nvSpPr>
+          <p:cNvPr id="49" name="Rectangle 48"/>
+          <p:cNvSpPr/>
+          <p:nvPr/>
+        </p:nvSpPr>
+        <p:spPr>
+          <a:xfrm>
+            <a:off x="3619195" y="3081528"/>
+            <a:ext cx="20116" cy="781811"/>
+          </a:xfrm>
+          <a:prstGeom prst="rect">
+            <a:avLst/>
+          </a:prstGeom>
+          <a:solidFill>
+            <a:srgbClr val="5FA8A0"/>
+          </a:solidFill>
+          <a:ln>
+            <a:noFill/>
+          </a:ln>
+        </p:spPr>
+        <p:style>
+          <a:lnRef idx="1">
+            <a:schemeClr val="accent1"/>
+          </a:lnRef>
+          <a:fillRef idx="3">
+            <a:schemeClr val="accent1"/>
+          </a:fillRef>
+          <a:effectRef idx="2">
+            <a:schemeClr val="accent1"/>
+          </a:effectRef>
+          <a:fontRef idx="minor">
+            <a:schemeClr val="lt1"/>
+          </a:fontRef>
+        </p:style>
+        <p:txBody>
+          <a:bodyPr rtlCol="0" anchor="ctr"/>
+          <a:lstStyle/>
+          <a:p>
+            <a:pPr algn="ctr"/>
+          </a:p>
+        </p:txBody>
+      </p:sp>
+      <p:sp>
+        <p:nvSpPr>
+          <p:cNvPr id="50" name="Rectangle 49"/>
+          <p:cNvSpPr/>
+          <p:nvPr/>
+        </p:nvSpPr>
+        <p:spPr>
+          <a:xfrm>
+            <a:off x="3429000" y="3454603"/>
+            <a:ext cx="214884" cy="20116"/>
+          </a:xfrm>
+          <a:prstGeom prst="rect">
+            <a:avLst/>
+          </a:prstGeom>
+          <a:solidFill>
+            <a:srgbClr val="5FA8A0"/>
+          </a:solidFill>
+          <a:ln>
+            <a:noFill/>
+          </a:ln>
+        </p:spPr>
+        <p:style>
+          <a:lnRef idx="1">
+            <a:schemeClr val="accent1"/>
+          </a:lnRef>
+          <a:fillRef idx="3">
+            <a:schemeClr val="accent1"/>
+          </a:fillRef>
+          <a:effectRef idx="2">
+            <a:schemeClr val="accent1"/>
+          </a:effectRef>
+          <a:fontRef idx="minor">
+            <a:schemeClr val="lt1"/>
+          </a:fontRef>
+        </p:style>
+        <p:txBody>
+          <a:bodyPr rtlCol="0" anchor="ctr"/>
+          <a:lstStyle/>
+          <a:p>
+            <a:pPr algn="ctr"/>
+          </a:p>
+        </p:txBody>
+      </p:sp>
+      <p:sp>
+        <p:nvSpPr>
+          <p:cNvPr id="51" name="Rectangle 50"/>
+          <p:cNvSpPr/>
+          <p:nvPr/>
+        </p:nvSpPr>
+        <p:spPr>
+          <a:xfrm>
+            <a:off x="3630168" y="3070555"/>
+            <a:ext cx="86867" cy="20116"/>
+          </a:xfrm>
+          <a:prstGeom prst="rect">
+            <a:avLst/>
+          </a:prstGeom>
+          <a:solidFill>
+            <a:srgbClr val="5FA8A0"/>
+          </a:solidFill>
+          <a:ln>
+            <a:noFill/>
+          </a:ln>
+        </p:spPr>
+        <p:style>
+          <a:lnRef idx="1">
+            <a:schemeClr val="accent1"/>
+          </a:lnRef>
+          <a:fillRef idx="3">
+            <a:schemeClr val="accent1"/>
+          </a:fillRef>
+          <a:effectRef idx="2">
+            <a:schemeClr val="accent1"/>
+          </a:effectRef>
+          <a:fontRef idx="minor">
+            <a:schemeClr val="lt1"/>
+          </a:fontRef>
+        </p:style>
+        <p:txBody>
+          <a:bodyPr rtlCol="0" anchor="ctr"/>
+          <a:lstStyle/>
+          <a:p>
+            <a:pPr algn="ctr"/>
+          </a:p>
+        </p:txBody>
+      </p:sp>
+      <p:sp>
+        <p:nvSpPr>
+          <p:cNvPr id="52" name="Rounded Rectangle 51"/>
+          <p:cNvSpPr/>
+          <p:nvPr/>
+        </p:nvSpPr>
+        <p:spPr>
+          <a:xfrm>
+            <a:off x="3703320" y="2916936"/>
+            <a:ext cx="2194560" cy="329184"/>
+          </a:xfrm>
+          <a:prstGeom prst="roundRect">
+            <a:avLst/>
+          </a:prstGeom>
+          <a:solidFill>
+            <a:srgbClr val="EDF2F7"/>
+          </a:solidFill>
+          <a:ln w="9525">
+            <a:solidFill>
+              <a:srgbClr val="5FA8A0"/>
+            </a:solidFill>
+          </a:ln>
+        </p:spPr>
+        <p:style>
+          <a:lnRef idx="1">
+            <a:schemeClr val="accent1"/>
+          </a:lnRef>
+          <a:fillRef idx="3">
+            <a:schemeClr val="accent1"/>
+          </a:fillRef>
+          <a:effectRef idx="2">
+            <a:schemeClr val="accent1"/>
+          </a:effectRef>
+          <a:fontRef idx="minor">
+            <a:schemeClr val="lt1"/>
+          </a:fontRef>
+        </p:style>
+        <p:txBody>
+          <a:bodyPr rtlCol="0" anchor="ctr"/>
+          <a:lstStyle/>
+          <a:p>
+            <a:pPr algn="ctr"/>
+          </a:p>
+        </p:txBody>
+      </p:sp>
+      <p:sp>
+        <p:nvSpPr>
+          <p:cNvPr id="53" name="TextBox 52"/>
+          <p:cNvSpPr txBox="1"/>
+          <p:nvPr/>
+        </p:nvSpPr>
+        <p:spPr>
+          <a:xfrm>
+            <a:off x="3794759" y="2953512"/>
+            <a:ext cx="2011679" cy="256031"/>
+          </a:xfrm>
+          <a:prstGeom prst="rect">
+            <a:avLst/>
+          </a:prstGeom>
+          <a:noFill/>
+        </p:spPr>
+        <p:txBody>
+          <a:bodyPr wrap="square">
+            <a:spAutoFit/>
+          </a:bodyPr>
+          <a:lstStyle/>
+          <a:p>
+            <a:pPr algn="l"/>
+            <a:r>
+              <a:rPr sz="800" b="0" i="0">
+                <a:solidFill>
+                  <a:srgbClr val="1A1A1A"/>
+                </a:solidFill>
+                <a:latin typeface="Segoe UI"/>
+              </a:rPr>
+              <a:t>Published Posts</a:t>
+            </a:r>
+          </a:p>
+        </p:txBody>
+      </p:sp>
+      <p:sp>
+        <p:nvSpPr>
+          <p:cNvPr id="54" name="Rectangle 53"/>
+          <p:cNvSpPr/>
+          <p:nvPr/>
+        </p:nvSpPr>
+        <p:spPr>
+          <a:xfrm>
+            <a:off x="3630168" y="3454603"/>
+            <a:ext cx="86867" cy="20116"/>
+          </a:xfrm>
+          <a:prstGeom prst="rect">
+            <a:avLst/>
+          </a:prstGeom>
+          <a:solidFill>
+            <a:srgbClr val="5FA8A0"/>
+          </a:solidFill>
+          <a:ln>
+            <a:noFill/>
+          </a:ln>
+        </p:spPr>
+        <p:style>
+          <a:lnRef idx="1">
+            <a:schemeClr val="accent1"/>
+          </a:lnRef>
+          <a:fillRef idx="3">
+            <a:schemeClr val="accent1"/>
+          </a:fillRef>
+          <a:effectRef idx="2">
+            <a:schemeClr val="accent1"/>
+          </a:effectRef>
+          <a:fontRef idx="minor">
+            <a:schemeClr val="lt1"/>
+          </a:fontRef>
+        </p:style>
+        <p:txBody>
+          <a:bodyPr rtlCol="0" anchor="ctr"/>
+          <a:lstStyle/>
+          <a:p>
+            <a:pPr algn="ctr"/>
+          </a:p>
+        </p:txBody>
+      </p:sp>
+      <p:sp>
+        <p:nvSpPr>
+          <p:cNvPr id="55" name="Rounded Rectangle 54"/>
+          <p:cNvSpPr/>
+          <p:nvPr/>
+        </p:nvSpPr>
+        <p:spPr>
+          <a:xfrm>
+            <a:off x="3703320" y="3300984"/>
+            <a:ext cx="2194560" cy="329184"/>
+          </a:xfrm>
+          <a:prstGeom prst="roundRect">
+            <a:avLst/>
+          </a:prstGeom>
+          <a:solidFill>
+            <a:srgbClr val="EDF2F7"/>
+          </a:solidFill>
+          <a:ln w="9525">
+            <a:solidFill>
+              <a:srgbClr val="5FA8A0"/>
+            </a:solidFill>
+          </a:ln>
+        </p:spPr>
+        <p:style>
+          <a:lnRef idx="1">
+            <a:schemeClr val="accent1"/>
+          </a:lnRef>
+          <a:fillRef idx="3">
+            <a:schemeClr val="accent1"/>
+          </a:fillRef>
+          <a:effectRef idx="2">
+            <a:schemeClr val="accent1"/>
+          </a:effectRef>
+          <a:fontRef idx="minor">
+            <a:schemeClr val="lt1"/>
+          </a:fontRef>
+        </p:style>
+        <p:txBody>
+          <a:bodyPr rtlCol="0" anchor="ctr"/>
+          <a:lstStyle/>
+          <a:p>
+            <a:pPr algn="ctr"/>
+          </a:p>
+        </p:txBody>
+      </p:sp>
+      <p:sp>
+        <p:nvSpPr>
+          <p:cNvPr id="56" name="TextBox 55"/>
+          <p:cNvSpPr txBox="1"/>
+          <p:nvPr/>
+        </p:nvSpPr>
+        <p:spPr>
+          <a:xfrm>
+            <a:off x="3794759" y="3337560"/>
+            <a:ext cx="2011679" cy="256031"/>
+          </a:xfrm>
+          <a:prstGeom prst="rect">
+            <a:avLst/>
+          </a:prstGeom>
+          <a:noFill/>
+        </p:spPr>
+        <p:txBody>
+          <a:bodyPr wrap="square">
+            <a:spAutoFit/>
+          </a:bodyPr>
+          <a:lstStyle/>
+          <a:p>
+            <a:pPr algn="l"/>
+            <a:r>
+              <a:rPr sz="800" b="0" i="0">
+                <a:solidFill>
+                  <a:srgbClr val="1A1A1A"/>
+                </a:solidFill>
+                <a:latin typeface="Segoe UI"/>
+              </a:rPr>
+              <a:t>Fan Contributions</a:t>
+            </a:r>
+          </a:p>
+        </p:txBody>
+      </p:sp>
+      <p:sp>
+        <p:nvSpPr>
+          <p:cNvPr id="57" name="Rectangle 56"/>
+          <p:cNvSpPr/>
+          <p:nvPr/>
+        </p:nvSpPr>
+        <p:spPr>
+          <a:xfrm>
+            <a:off x="6088075" y="3273552"/>
+            <a:ext cx="20116" cy="397763"/>
+          </a:xfrm>
+          <a:prstGeom prst="rect">
+            <a:avLst/>
+          </a:prstGeom>
+          <a:solidFill>
+            <a:srgbClr val="5FA8A0"/>
+          </a:solidFill>
+          <a:ln>
+            <a:noFill/>
+          </a:ln>
+        </p:spPr>
+        <p:style>
+          <a:lnRef idx="1">
+            <a:schemeClr val="accent1"/>
+          </a:lnRef>
+          <a:fillRef idx="3">
+            <a:schemeClr val="accent1"/>
+          </a:fillRef>
+          <a:effectRef idx="2">
+            <a:schemeClr val="accent1"/>
+          </a:effectRef>
+          <a:fontRef idx="minor">
+            <a:schemeClr val="lt1"/>
+          </a:fontRef>
+        </p:style>
+        <p:txBody>
+          <a:bodyPr rtlCol="0" anchor="ctr"/>
+          <a:lstStyle/>
+          <a:p>
+            <a:pPr algn="ctr"/>
+          </a:p>
+        </p:txBody>
+      </p:sp>
+      <p:sp>
+        <p:nvSpPr>
+          <p:cNvPr id="58" name="Rectangle 57"/>
+          <p:cNvSpPr/>
+          <p:nvPr/>
+        </p:nvSpPr>
+        <p:spPr>
+          <a:xfrm>
+            <a:off x="5897879" y="3454603"/>
+            <a:ext cx="214884" cy="20116"/>
+          </a:xfrm>
+          <a:prstGeom prst="rect">
+            <a:avLst/>
+          </a:prstGeom>
+          <a:solidFill>
+            <a:srgbClr val="5FA8A0"/>
+          </a:solidFill>
+          <a:ln>
+            <a:noFill/>
+          </a:ln>
+        </p:spPr>
+        <p:style>
+          <a:lnRef idx="1">
+            <a:schemeClr val="accent1"/>
+          </a:lnRef>
+          <a:fillRef idx="3">
+            <a:schemeClr val="accent1"/>
+          </a:fillRef>
+          <a:effectRef idx="2">
+            <a:schemeClr val="accent1"/>
+          </a:effectRef>
+          <a:fontRef idx="minor">
+            <a:schemeClr val="lt1"/>
+          </a:fontRef>
+        </p:style>
+        <p:txBody>
+          <a:bodyPr rtlCol="0" anchor="ctr"/>
+          <a:lstStyle/>
+          <a:p>
+            <a:pPr algn="ctr"/>
+          </a:p>
+        </p:txBody>
+      </p:sp>
+      <p:sp>
+        <p:nvSpPr>
+          <p:cNvPr id="59" name="Rectangle 58"/>
+          <p:cNvSpPr/>
+          <p:nvPr/>
+        </p:nvSpPr>
+        <p:spPr>
+          <a:xfrm>
+            <a:off x="6099048" y="3262579"/>
+            <a:ext cx="86868" cy="20116"/>
+          </a:xfrm>
+          <a:prstGeom prst="rect">
+            <a:avLst/>
+          </a:prstGeom>
+          <a:solidFill>
+            <a:srgbClr val="5FA8A0"/>
+          </a:solidFill>
+          <a:ln>
+            <a:noFill/>
+          </a:ln>
+        </p:spPr>
+        <p:style>
+          <a:lnRef idx="1">
+            <a:schemeClr val="accent1"/>
+          </a:lnRef>
+          <a:fillRef idx="3">
+            <a:schemeClr val="accent1"/>
+          </a:fillRef>
+          <a:effectRef idx="2">
+            <a:schemeClr val="accent1"/>
+          </a:effectRef>
+          <a:fontRef idx="minor">
+            <a:schemeClr val="lt1"/>
+          </a:fontRef>
+        </p:style>
+        <p:txBody>
+          <a:bodyPr rtlCol="0" anchor="ctr"/>
+          <a:lstStyle/>
+          <a:p>
+            <a:pPr algn="ctr"/>
+          </a:p>
+        </p:txBody>
+      </p:sp>
+      <p:sp>
+        <p:nvSpPr>
+          <p:cNvPr id="60" name="Rounded Rectangle 59"/>
+          <p:cNvSpPr/>
+          <p:nvPr/>
+        </p:nvSpPr>
+        <p:spPr>
+          <a:xfrm>
+            <a:off x="6172200" y="3108960"/>
+            <a:ext cx="2011680" cy="329184"/>
+          </a:xfrm>
+          <a:prstGeom prst="roundRect">
+            <a:avLst/>
+          </a:prstGeom>
+          <a:solidFill>
+            <a:srgbClr val="F5F8FC"/>
+          </a:solidFill>
+          <a:ln w="9525">
+            <a:solidFill>
+              <a:srgbClr val="5FA8A0"/>
+            </a:solidFill>
+          </a:ln>
+        </p:spPr>
+        <p:style>
+          <a:lnRef idx="1">
+            <a:schemeClr val="accent1"/>
+          </a:lnRef>
+          <a:fillRef idx="3">
+            <a:schemeClr val="accent1"/>
+          </a:fillRef>
+          <a:effectRef idx="2">
+            <a:schemeClr val="accent1"/>
+          </a:effectRef>
+          <a:fontRef idx="minor">
+            <a:schemeClr val="lt1"/>
+          </a:fontRef>
+        </p:style>
+        <p:txBody>
+          <a:bodyPr rtlCol="0" anchor="ctr"/>
+          <a:lstStyle/>
+          <a:p>
+            <a:pPr algn="ctr"/>
+          </a:p>
+        </p:txBody>
+      </p:sp>
+      <p:sp>
+        <p:nvSpPr>
+          <p:cNvPr id="61" name="TextBox 60"/>
+          <p:cNvSpPr txBox="1"/>
+          <p:nvPr/>
+        </p:nvSpPr>
+        <p:spPr>
+          <a:xfrm>
+            <a:off x="6263640" y="3145536"/>
+            <a:ext cx="1828800" cy="256031"/>
+          </a:xfrm>
+          <a:prstGeom prst="rect">
+            <a:avLst/>
+          </a:prstGeom>
+          <a:noFill/>
+        </p:spPr>
+        <p:txBody>
+          <a:bodyPr wrap="square">
+            <a:spAutoFit/>
+          </a:bodyPr>
+          <a:lstStyle/>
+          <a:p>
+            <a:pPr algn="l"/>
+            <a:r>
+              <a:rPr sz="800" b="0" i="0">
+                <a:solidFill>
+                  <a:srgbClr val="6B7280"/>
+                </a:solidFill>
+                <a:latin typeface="Segoe UI"/>
+              </a:rPr>
+              <a:t>Submission Form</a:t>
+            </a:r>
+          </a:p>
+        </p:txBody>
+      </p:sp>
+      <p:sp>
+        <p:nvSpPr>
+          <p:cNvPr id="62" name="Rectangle 61"/>
+          <p:cNvSpPr/>
+          <p:nvPr/>
+        </p:nvSpPr>
+        <p:spPr>
+          <a:xfrm>
+            <a:off x="6099048" y="3646627"/>
+            <a:ext cx="86868" cy="20116"/>
+          </a:xfrm>
+          <a:prstGeom prst="rect">
+            <a:avLst/>
+          </a:prstGeom>
+          <a:solidFill>
+            <a:srgbClr val="5FA8A0"/>
+          </a:solidFill>
+          <a:ln>
+            <a:noFill/>
+          </a:ln>
+        </p:spPr>
+        <p:style>
+          <a:lnRef idx="1">
+            <a:schemeClr val="accent1"/>
+          </a:lnRef>
+          <a:fillRef idx="3">
+            <a:schemeClr val="accent1"/>
+          </a:fillRef>
+          <a:effectRef idx="2">
+            <a:schemeClr val="accent1"/>
+          </a:effectRef>
+          <a:fontRef idx="minor">
+            <a:schemeClr val="lt1"/>
+          </a:fontRef>
+        </p:style>
+        <p:txBody>
+          <a:bodyPr rtlCol="0" anchor="ctr"/>
+          <a:lstStyle/>
+          <a:p>
+            <a:pPr algn="ctr"/>
+          </a:p>
+        </p:txBody>
+      </p:sp>
+      <p:sp>
+        <p:nvSpPr>
+          <p:cNvPr id="63" name="Rounded Rectangle 62"/>
+          <p:cNvSpPr/>
+          <p:nvPr/>
+        </p:nvSpPr>
+        <p:spPr>
+          <a:xfrm>
+            <a:off x="6172200" y="3493008"/>
+            <a:ext cx="2011680" cy="329184"/>
+          </a:xfrm>
+          <a:prstGeom prst="roundRect">
+            <a:avLst/>
+          </a:prstGeom>
+          <a:solidFill>
+            <a:srgbClr val="F5F8FC"/>
+          </a:solidFill>
+          <a:ln w="9525">
+            <a:solidFill>
+              <a:srgbClr val="5FA8A0"/>
+            </a:solidFill>
+          </a:ln>
+        </p:spPr>
+        <p:style>
+          <a:lnRef idx="1">
+            <a:schemeClr val="accent1"/>
+          </a:lnRef>
+          <a:fillRef idx="3">
+            <a:schemeClr val="accent1"/>
+          </a:fillRef>
+          <a:effectRef idx="2">
+            <a:schemeClr val="accent1"/>
+          </a:effectRef>
+          <a:fontRef idx="minor">
+            <a:schemeClr val="lt1"/>
+          </a:fontRef>
+        </p:style>
+        <p:txBody>
+          <a:bodyPr rtlCol="0" anchor="ctr"/>
+          <a:lstStyle/>
+          <a:p>
+            <a:pPr algn="ctr"/>
+          </a:p>
+        </p:txBody>
+      </p:sp>
+      <p:sp>
+        <p:nvSpPr>
+          <p:cNvPr id="64" name="TextBox 63"/>
+          <p:cNvSpPr txBox="1"/>
+          <p:nvPr/>
+        </p:nvSpPr>
+        <p:spPr>
+          <a:xfrm>
+            <a:off x="6263640" y="3529584"/>
+            <a:ext cx="1828800" cy="256031"/>
+          </a:xfrm>
+          <a:prstGeom prst="rect">
+            <a:avLst/>
+          </a:prstGeom>
+          <a:noFill/>
+        </p:spPr>
+        <p:txBody>
+          <a:bodyPr wrap="square">
+            <a:spAutoFit/>
+          </a:bodyPr>
+          <a:lstStyle/>
+          <a:p>
+            <a:pPr algn="l"/>
+            <a:r>
+              <a:rPr sz="800" b="0" i="0">
+                <a:solidFill>
+                  <a:srgbClr val="6B7280"/>
+                </a:solidFill>
+                <a:latin typeface="Segoe UI"/>
+              </a:rPr>
+              <a:t>Published Article</a:t>
+            </a:r>
+          </a:p>
+        </p:txBody>
+      </p:sp>
+      <p:sp>
+        <p:nvSpPr>
+          <p:cNvPr id="65" name="Rectangle 64"/>
+          <p:cNvSpPr/>
+          <p:nvPr/>
+        </p:nvSpPr>
+        <p:spPr>
+          <a:xfrm>
+            <a:off x="3630168" y="3838651"/>
+            <a:ext cx="86867" cy="20116"/>
+          </a:xfrm>
+          <a:prstGeom prst="rect">
+            <a:avLst/>
+          </a:prstGeom>
+          <a:solidFill>
+            <a:srgbClr val="5FA8A0"/>
+          </a:solidFill>
+          <a:ln>
+            <a:noFill/>
+          </a:ln>
+        </p:spPr>
+        <p:style>
+          <a:lnRef idx="1">
+            <a:schemeClr val="accent1"/>
+          </a:lnRef>
+          <a:fillRef idx="3">
+            <a:schemeClr val="accent1"/>
+          </a:fillRef>
+          <a:effectRef idx="2">
+            <a:schemeClr val="accent1"/>
+          </a:effectRef>
+          <a:fontRef idx="minor">
+            <a:schemeClr val="lt1"/>
+          </a:fontRef>
+        </p:style>
+        <p:txBody>
+          <a:bodyPr rtlCol="0" anchor="ctr"/>
+          <a:lstStyle/>
+          <a:p>
+            <a:pPr algn="ctr"/>
+          </a:p>
+        </p:txBody>
+      </p:sp>
+      <p:sp>
+        <p:nvSpPr>
+          <p:cNvPr id="66" name="Rounded Rectangle 65"/>
+          <p:cNvSpPr/>
+          <p:nvPr/>
+        </p:nvSpPr>
+        <p:spPr>
+          <a:xfrm>
+            <a:off x="3703320" y="3685032"/>
+            <a:ext cx="2194560" cy="329184"/>
+          </a:xfrm>
+          <a:prstGeom prst="roundRect">
+            <a:avLst/>
+          </a:prstGeom>
+          <a:solidFill>
+            <a:srgbClr val="EDF2F7"/>
+          </a:solidFill>
+          <a:ln w="9525">
+            <a:solidFill>
+              <a:srgbClr val="5FA8A0"/>
+            </a:solidFill>
+          </a:ln>
+        </p:spPr>
+        <p:style>
+          <a:lnRef idx="1">
+            <a:schemeClr val="accent1"/>
+          </a:lnRef>
+          <a:fillRef idx="3">
+            <a:schemeClr val="accent1"/>
+          </a:fillRef>
+          <a:effectRef idx="2">
+            <a:schemeClr val="accent1"/>
+          </a:effectRef>
+          <a:fontRef idx="minor">
+            <a:schemeClr val="lt1"/>
+          </a:fontRef>
+        </p:style>
+        <p:txBody>
+          <a:bodyPr rtlCol="0" anchor="ctr"/>
+          <a:lstStyle/>
+          <a:p>
+            <a:pPr algn="ctr"/>
+          </a:p>
+        </p:txBody>
+      </p:sp>
+      <p:sp>
+        <p:nvSpPr>
+          <p:cNvPr id="67" name="TextBox 66"/>
+          <p:cNvSpPr txBox="1"/>
+          <p:nvPr/>
+        </p:nvSpPr>
+        <p:spPr>
+          <a:xfrm>
+            <a:off x="3794759" y="3721608"/>
+            <a:ext cx="2011679" cy="256031"/>
+          </a:xfrm>
+          <a:prstGeom prst="rect">
+            <a:avLst/>
+          </a:prstGeom>
+          <a:noFill/>
+        </p:spPr>
+        <p:txBody>
+          <a:bodyPr wrap="square">
+            <a:spAutoFit/>
+          </a:bodyPr>
+          <a:lstStyle/>
+          <a:p>
+            <a:pPr algn="l"/>
+            <a:r>
+              <a:rPr sz="800" b="0" i="0">
+                <a:solidFill>
+                  <a:srgbClr val="1A1A1A"/>
+                </a:solidFill>
+                <a:latin typeface="Segoe UI"/>
+              </a:rPr>
+              <a:t>Submission Guidelines</a:t>
+            </a:r>
+          </a:p>
+        </p:txBody>
+      </p:sp>
+      <p:sp>
+        <p:nvSpPr>
+          <p:cNvPr id="68" name="Rectangle 67"/>
+          <p:cNvSpPr/>
+          <p:nvPr/>
+        </p:nvSpPr>
+        <p:spPr>
+          <a:xfrm>
+            <a:off x="1892807" y="4661611"/>
+            <a:ext cx="86868" cy="20116"/>
+          </a:xfrm>
+          <a:prstGeom prst="rect">
+            <a:avLst/>
+          </a:prstGeom>
+          <a:solidFill>
+            <a:srgbClr val="D48F0A"/>
+          </a:solidFill>
+          <a:ln>
+            <a:noFill/>
+          </a:ln>
+        </p:spPr>
+        <p:style>
+          <a:lnRef idx="1">
+            <a:schemeClr val="accent1"/>
+          </a:lnRef>
+          <a:fillRef idx="3">
+            <a:schemeClr val="accent1"/>
+          </a:fillRef>
+          <a:effectRef idx="2">
+            <a:schemeClr val="accent1"/>
+          </a:effectRef>
+          <a:fontRef idx="minor">
+            <a:schemeClr val="lt1"/>
+          </a:fontRef>
+        </p:style>
+        <p:txBody>
+          <a:bodyPr rtlCol="0" anchor="ctr"/>
+          <a:lstStyle/>
+          <a:p>
+            <a:pPr algn="ctr"/>
+          </a:p>
+        </p:txBody>
+      </p:sp>
+      <p:sp>
+        <p:nvSpPr>
+          <p:cNvPr id="69" name="Rounded Rectangle 68"/>
+          <p:cNvSpPr/>
+          <p:nvPr/>
+        </p:nvSpPr>
+        <p:spPr>
+          <a:xfrm>
+            <a:off x="1965960" y="4480560"/>
+            <a:ext cx="1463040" cy="384048"/>
+          </a:xfrm>
+          <a:prstGeom prst="roundRect">
+            <a:avLst/>
+          </a:prstGeom>
+          <a:solidFill>
+            <a:srgbClr val="D48F0A"/>
+          </a:solidFill>
+          <a:ln w="12700">
+            <a:solidFill>
+              <a:srgbClr val="D48F0A"/>
+            </a:solidFill>
+          </a:ln>
+        </p:spPr>
+        <p:style>
+          <a:lnRef idx="1">
+            <a:schemeClr val="accent1"/>
+          </a:lnRef>
+          <a:fillRef idx="3">
+            <a:schemeClr val="accent1"/>
+          </a:fillRef>
+          <a:effectRef idx="2">
+            <a:schemeClr val="accent1"/>
+          </a:effectRef>
+          <a:fontRef idx="minor">
+            <a:schemeClr val="lt1"/>
+          </a:fontRef>
+        </p:style>
+        <p:txBody>
+          <a:bodyPr rtlCol="0" anchor="ctr"/>
+          <a:lstStyle/>
+          <a:p>
+            <a:pPr algn="ctr"/>
+          </a:p>
+        </p:txBody>
+      </p:sp>
+      <p:sp>
+        <p:nvSpPr>
+          <p:cNvPr id="70" name="TextBox 69"/>
+          <p:cNvSpPr txBox="1"/>
+          <p:nvPr/>
+        </p:nvSpPr>
+        <p:spPr>
+          <a:xfrm>
+            <a:off x="1965960" y="4480560"/>
+            <a:ext cx="1463040" cy="384048"/>
+          </a:xfrm>
+          <a:prstGeom prst="rect">
+            <a:avLst/>
+          </a:prstGeom>
+          <a:noFill/>
+        </p:spPr>
+        <p:txBody>
+          <a:bodyPr wrap="square">
+            <a:spAutoFit/>
+          </a:bodyPr>
+          <a:lstStyle/>
+          <a:p>
+            <a:pPr algn="ctr"/>
+            <a:r>
+              <a:rPr sz="900" b="1" i="0">
+                <a:solidFill>
+                  <a:srgbClr val="FFFFFF"/>
+                </a:solidFill>
+                <a:latin typeface="Segoe UI"/>
+              </a:rPr>
+              <a:t>Shows</a:t>
+            </a:r>
+          </a:p>
+        </p:txBody>
+      </p:sp>
+      <p:sp>
+        <p:nvSpPr>
+          <p:cNvPr id="71" name="Rectangle 70"/>
+          <p:cNvSpPr/>
+          <p:nvPr/>
+        </p:nvSpPr>
+        <p:spPr>
+          <a:xfrm>
+            <a:off x="3619195" y="4288536"/>
+            <a:ext cx="20116" cy="781811"/>
+          </a:xfrm>
+          <a:prstGeom prst="rect">
+            <a:avLst/>
+          </a:prstGeom>
+          <a:solidFill>
+            <a:srgbClr val="D48F0A"/>
+          </a:solidFill>
+          <a:ln>
+            <a:noFill/>
+          </a:ln>
+        </p:spPr>
+        <p:style>
+          <a:lnRef idx="1">
+            <a:schemeClr val="accent1"/>
+          </a:lnRef>
+          <a:fillRef idx="3">
+            <a:schemeClr val="accent1"/>
+          </a:fillRef>
+          <a:effectRef idx="2">
+            <a:schemeClr val="accent1"/>
+          </a:effectRef>
+          <a:fontRef idx="minor">
+            <a:schemeClr val="lt1"/>
+          </a:fontRef>
+        </p:style>
+        <p:txBody>
+          <a:bodyPr rtlCol="0" anchor="ctr"/>
+          <a:lstStyle/>
+          <a:p>
+            <a:pPr algn="ctr"/>
+          </a:p>
+        </p:txBody>
+      </p:sp>
+      <p:sp>
+        <p:nvSpPr>
+          <p:cNvPr id="72" name="Rectangle 71"/>
+          <p:cNvSpPr/>
+          <p:nvPr/>
+        </p:nvSpPr>
+        <p:spPr>
+          <a:xfrm>
+            <a:off x="3429000" y="4661611"/>
+            <a:ext cx="214884" cy="20116"/>
+          </a:xfrm>
+          <a:prstGeom prst="rect">
+            <a:avLst/>
+          </a:prstGeom>
+          <a:solidFill>
+            <a:srgbClr val="D48F0A"/>
+          </a:solidFill>
+          <a:ln>
+            <a:noFill/>
+          </a:ln>
+        </p:spPr>
+        <p:style>
+          <a:lnRef idx="1">
+            <a:schemeClr val="accent1"/>
+          </a:lnRef>
+          <a:fillRef idx="3">
+            <a:schemeClr val="accent1"/>
+          </a:fillRef>
+          <a:effectRef idx="2">
+            <a:schemeClr val="accent1"/>
+          </a:effectRef>
+          <a:fontRef idx="minor">
+            <a:schemeClr val="lt1"/>
+          </a:fontRef>
+        </p:style>
+        <p:txBody>
+          <a:bodyPr rtlCol="0" anchor="ctr"/>
+          <a:lstStyle/>
+          <a:p>
+            <a:pPr algn="ctr"/>
+          </a:p>
+        </p:txBody>
+      </p:sp>
+      <p:sp>
+        <p:nvSpPr>
+          <p:cNvPr id="73" name="Rectangle 72"/>
+          <p:cNvSpPr/>
+          <p:nvPr/>
+        </p:nvSpPr>
+        <p:spPr>
+          <a:xfrm>
+            <a:off x="3630168" y="4277563"/>
+            <a:ext cx="86867" cy="20116"/>
+          </a:xfrm>
+          <a:prstGeom prst="rect">
+            <a:avLst/>
+          </a:prstGeom>
+          <a:solidFill>
+            <a:srgbClr val="D48F0A"/>
+          </a:solidFill>
+          <a:ln>
+            <a:noFill/>
+          </a:ln>
+        </p:spPr>
+        <p:style>
+          <a:lnRef idx="1">
+            <a:schemeClr val="accent1"/>
+          </a:lnRef>
+          <a:fillRef idx="3">
+            <a:schemeClr val="accent1"/>
+          </a:fillRef>
+          <a:effectRef idx="2">
+            <a:schemeClr val="accent1"/>
+          </a:effectRef>
+          <a:fontRef idx="minor">
+            <a:schemeClr val="lt1"/>
+          </a:fontRef>
+        </p:style>
+        <p:txBody>
+          <a:bodyPr rtlCol="0" anchor="ctr"/>
+          <a:lstStyle/>
+          <a:p>
+            <a:pPr algn="ctr"/>
+          </a:p>
+        </p:txBody>
+      </p:sp>
+      <p:sp>
+        <p:nvSpPr>
+          <p:cNvPr id="74" name="Rounded Rectangle 73"/>
+          <p:cNvSpPr/>
+          <p:nvPr/>
+        </p:nvSpPr>
+        <p:spPr>
+          <a:xfrm>
+            <a:off x="3703320" y="4123944"/>
+            <a:ext cx="2194560" cy="329184"/>
+          </a:xfrm>
+          <a:prstGeom prst="roundRect">
+            <a:avLst/>
+          </a:prstGeom>
+          <a:solidFill>
+            <a:srgbClr val="EDF2F7"/>
+          </a:solidFill>
+          <a:ln w="9525">
+            <a:solidFill>
+              <a:srgbClr val="D48F0A"/>
+            </a:solidFill>
+          </a:ln>
+        </p:spPr>
+        <p:style>
+          <a:lnRef idx="1">
+            <a:schemeClr val="accent1"/>
+          </a:lnRef>
+          <a:fillRef idx="3">
+            <a:schemeClr val="accent1"/>
+          </a:fillRef>
+          <a:effectRef idx="2">
+            <a:schemeClr val="accent1"/>
+          </a:effectRef>
+          <a:fontRef idx="minor">
+            <a:schemeClr val="lt1"/>
+          </a:fontRef>
+        </p:style>
+        <p:txBody>
+          <a:bodyPr rtlCol="0" anchor="ctr"/>
+          <a:lstStyle/>
+          <a:p>
+            <a:pPr algn="ctr"/>
+          </a:p>
+        </p:txBody>
+      </p:sp>
+      <p:sp>
+        <p:nvSpPr>
+          <p:cNvPr id="75" name="TextBox 74"/>
+          <p:cNvSpPr txBox="1"/>
+          <p:nvPr/>
+        </p:nvSpPr>
+        <p:spPr>
+          <a:xfrm>
+            <a:off x="3794759" y="4160520"/>
+            <a:ext cx="2011679" cy="256031"/>
+          </a:xfrm>
+          <a:prstGeom prst="rect">
+            <a:avLst/>
+          </a:prstGeom>
+          <a:noFill/>
+        </p:spPr>
+        <p:txBody>
+          <a:bodyPr wrap="square">
+            <a:spAutoFit/>
+          </a:bodyPr>
+          <a:lstStyle/>
+          <a:p>
+            <a:pPr algn="l"/>
+            <a:r>
+              <a:rPr sz="800" b="0" i="0">
+                <a:solidFill>
+                  <a:srgbClr val="1A1A1A"/>
+                </a:solidFill>
+                <a:latin typeface="Segoe UI"/>
+              </a:rPr>
+              <a:t>Show Details</a:t>
+            </a:r>
+          </a:p>
+        </p:txBody>
+      </p:sp>
+      <p:sp>
+        <p:nvSpPr>
+          <p:cNvPr id="76" name="Rectangle 75"/>
+          <p:cNvSpPr/>
+          <p:nvPr/>
+        </p:nvSpPr>
+        <p:spPr>
+          <a:xfrm>
+            <a:off x="6088075" y="4096511"/>
+            <a:ext cx="20116" cy="397763"/>
+          </a:xfrm>
+          <a:prstGeom prst="rect">
+            <a:avLst/>
+          </a:prstGeom>
+          <a:solidFill>
+            <a:srgbClr val="D48F0A"/>
+          </a:solidFill>
+          <a:ln>
+            <a:noFill/>
+          </a:ln>
+        </p:spPr>
+        <p:style>
+          <a:lnRef idx="1">
+            <a:schemeClr val="accent1"/>
+          </a:lnRef>
+          <a:fillRef idx="3">
+            <a:schemeClr val="accent1"/>
+          </a:fillRef>
+          <a:effectRef idx="2">
+            <a:schemeClr val="accent1"/>
+          </a:effectRef>
+          <a:fontRef idx="minor">
+            <a:schemeClr val="lt1"/>
+          </a:fontRef>
+        </p:style>
+        <p:txBody>
+          <a:bodyPr rtlCol="0" anchor="ctr"/>
+          <a:lstStyle/>
+          <a:p>
+            <a:pPr algn="ctr"/>
+          </a:p>
+        </p:txBody>
+      </p:sp>
+      <p:sp>
+        <p:nvSpPr>
+          <p:cNvPr id="77" name="Rectangle 76"/>
+          <p:cNvSpPr/>
+          <p:nvPr/>
+        </p:nvSpPr>
+        <p:spPr>
+          <a:xfrm>
+            <a:off x="5897879" y="4277563"/>
+            <a:ext cx="214884" cy="20116"/>
+          </a:xfrm>
+          <a:prstGeom prst="rect">
+            <a:avLst/>
+          </a:prstGeom>
+          <a:solidFill>
+            <a:srgbClr val="D48F0A"/>
+          </a:solidFill>
+          <a:ln>
+            <a:noFill/>
+          </a:ln>
+        </p:spPr>
+        <p:style>
+          <a:lnRef idx="1">
+            <a:schemeClr val="accent1"/>
+          </a:lnRef>
+          <a:fillRef idx="3">
+            <a:schemeClr val="accent1"/>
+          </a:fillRef>
+          <a:effectRef idx="2">
+            <a:schemeClr val="accent1"/>
+          </a:effectRef>
+          <a:fontRef idx="minor">
+            <a:schemeClr val="lt1"/>
+          </a:fontRef>
+        </p:style>
+        <p:txBody>
+          <a:bodyPr rtlCol="0" anchor="ctr"/>
+          <a:lstStyle/>
+          <a:p>
+            <a:pPr algn="ctr"/>
+          </a:p>
+        </p:txBody>
+      </p:sp>
+      <p:sp>
+        <p:nvSpPr>
+          <p:cNvPr id="78" name="Rectangle 77"/>
+          <p:cNvSpPr/>
+          <p:nvPr/>
+        </p:nvSpPr>
+        <p:spPr>
+          <a:xfrm>
+            <a:off x="6099048" y="4085539"/>
+            <a:ext cx="86868" cy="20116"/>
+          </a:xfrm>
+          <a:prstGeom prst="rect">
+            <a:avLst/>
+          </a:prstGeom>
+          <a:solidFill>
+            <a:srgbClr val="D48F0A"/>
+          </a:solidFill>
+          <a:ln>
+            <a:noFill/>
+          </a:ln>
+        </p:spPr>
+        <p:style>
+          <a:lnRef idx="1">
+            <a:schemeClr val="accent1"/>
+          </a:lnRef>
+          <a:fillRef idx="3">
+            <a:schemeClr val="accent1"/>
+          </a:fillRef>
+          <a:effectRef idx="2">
+            <a:schemeClr val="accent1"/>
+          </a:effectRef>
+          <a:fontRef idx="minor">
+            <a:schemeClr val="lt1"/>
+          </a:fontRef>
+        </p:style>
+        <p:txBody>
+          <a:bodyPr rtlCol="0" anchor="ctr"/>
+          <a:lstStyle/>
+          <a:p>
+            <a:pPr algn="ctr"/>
+          </a:p>
+        </p:txBody>
+      </p:sp>
+      <p:sp>
+        <p:nvSpPr>
+          <p:cNvPr id="79" name="Rounded Rectangle 78"/>
+          <p:cNvSpPr/>
+          <p:nvPr/>
+        </p:nvSpPr>
+        <p:spPr>
+          <a:xfrm>
+            <a:off x="6172200" y="3931920"/>
+            <a:ext cx="2011680" cy="329184"/>
+          </a:xfrm>
+          <a:prstGeom prst="roundRect">
+            <a:avLst/>
+          </a:prstGeom>
+          <a:solidFill>
+            <a:srgbClr val="F5F8FC"/>
+          </a:solidFill>
+          <a:ln w="9525">
+            <a:solidFill>
+              <a:srgbClr val="D48F0A"/>
+            </a:solidFill>
+          </a:ln>
+        </p:spPr>
+        <p:style>
+          <a:lnRef idx="1">
+            <a:schemeClr val="accent1"/>
+          </a:lnRef>
+          <a:fillRef idx="3">
+            <a:schemeClr val="accent1"/>
+          </a:fillRef>
+          <a:effectRef idx="2">
+            <a:schemeClr val="accent1"/>
+          </a:effectRef>
+          <a:fontRef idx="minor">
+            <a:schemeClr val="lt1"/>
+          </a:fontRef>
+        </p:style>
+        <p:txBody>
+          <a:bodyPr rtlCol="0" anchor="ctr"/>
+          <a:lstStyle/>
+          <a:p>
+            <a:pPr algn="ctr"/>
+          </a:p>
+        </p:txBody>
+      </p:sp>
+      <p:sp>
+        <p:nvSpPr>
+          <p:cNvPr id="80" name="TextBox 79"/>
+          <p:cNvSpPr txBox="1"/>
+          <p:nvPr/>
+        </p:nvSpPr>
+        <p:spPr>
+          <a:xfrm>
+            <a:off x="6263640" y="3968496"/>
+            <a:ext cx="1828800" cy="256031"/>
+          </a:xfrm>
+          <a:prstGeom prst="rect">
+            <a:avLst/>
+          </a:prstGeom>
+          <a:noFill/>
+        </p:spPr>
+        <p:txBody>
+          <a:bodyPr wrap="square">
+            <a:spAutoFit/>
+          </a:bodyPr>
+          <a:lstStyle/>
+          <a:p>
+            <a:pPr algn="l"/>
+            <a:r>
+              <a:rPr sz="800" b="0" i="0">
+                <a:solidFill>
+                  <a:srgbClr val="6B7280"/>
+                </a:solidFill>
+                <a:latin typeface="Segoe UI"/>
+              </a:rPr>
+              <a:t>Date</a:t>
+            </a:r>
+          </a:p>
+        </p:txBody>
+      </p:sp>
+      <p:sp>
+        <p:nvSpPr>
+          <p:cNvPr id="81" name="Rectangle 80"/>
+          <p:cNvSpPr/>
+          <p:nvPr/>
+        </p:nvSpPr>
+        <p:spPr>
+          <a:xfrm>
+            <a:off x="6099048" y="4469587"/>
+            <a:ext cx="86868" cy="20116"/>
+          </a:xfrm>
+          <a:prstGeom prst="rect">
+            <a:avLst/>
+          </a:prstGeom>
+          <a:solidFill>
+            <a:srgbClr val="D48F0A"/>
+          </a:solidFill>
+          <a:ln>
+            <a:noFill/>
+          </a:ln>
+        </p:spPr>
+        <p:style>
+          <a:lnRef idx="1">
+            <a:schemeClr val="accent1"/>
+          </a:lnRef>
+          <a:fillRef idx="3">
+            <a:schemeClr val="accent1"/>
+          </a:fillRef>
+          <a:effectRef idx="2">
+            <a:schemeClr val="accent1"/>
+          </a:effectRef>
+          <a:fontRef idx="minor">
+            <a:schemeClr val="lt1"/>
+          </a:fontRef>
+        </p:style>
+        <p:txBody>
+          <a:bodyPr rtlCol="0" anchor="ctr"/>
+          <a:lstStyle/>
+          <a:p>
+            <a:pPr algn="ctr"/>
+          </a:p>
+        </p:txBody>
+      </p:sp>
+      <p:sp>
+        <p:nvSpPr>
+          <p:cNvPr id="82" name="Rounded Rectangle 81"/>
+          <p:cNvSpPr/>
+          <p:nvPr/>
+        </p:nvSpPr>
+        <p:spPr>
+          <a:xfrm>
+            <a:off x="6172200" y="4315968"/>
+            <a:ext cx="2011680" cy="329184"/>
+          </a:xfrm>
+          <a:prstGeom prst="roundRect">
+            <a:avLst/>
+          </a:prstGeom>
+          <a:solidFill>
+            <a:srgbClr val="F5F8FC"/>
+          </a:solidFill>
+          <a:ln w="9525">
+            <a:solidFill>
+              <a:srgbClr val="D48F0A"/>
+            </a:solidFill>
+          </a:ln>
+        </p:spPr>
+        <p:style>
+          <a:lnRef idx="1">
+            <a:schemeClr val="accent1"/>
+          </a:lnRef>
+          <a:fillRef idx="3">
+            <a:schemeClr val="accent1"/>
+          </a:fillRef>
+          <a:effectRef idx="2">
+            <a:schemeClr val="accent1"/>
+          </a:effectRef>
+          <a:fontRef idx="minor">
+            <a:schemeClr val="lt1"/>
+          </a:fontRef>
+        </p:style>
+        <p:txBody>
+          <a:bodyPr rtlCol="0" anchor="ctr"/>
+          <a:lstStyle/>
+          <a:p>
+            <a:pPr algn="ctr"/>
+          </a:p>
+        </p:txBody>
+      </p:sp>
+      <p:sp>
+        <p:nvSpPr>
+          <p:cNvPr id="83" name="TextBox 82"/>
+          <p:cNvSpPr txBox="1"/>
+          <p:nvPr/>
+        </p:nvSpPr>
+        <p:spPr>
+          <a:xfrm>
+            <a:off x="6263640" y="4352544"/>
+            <a:ext cx="1828800" cy="256031"/>
+          </a:xfrm>
+          <a:prstGeom prst="rect">
+            <a:avLst/>
+          </a:prstGeom>
+          <a:noFill/>
+        </p:spPr>
+        <p:txBody>
+          <a:bodyPr wrap="square">
+            <a:spAutoFit/>
+          </a:bodyPr>
+          <a:lstStyle/>
+          <a:p>
+            <a:pPr algn="l"/>
+            <a:r>
+              <a:rPr sz="800" b="0" i="0">
+                <a:solidFill>
+                  <a:srgbClr val="6B7280"/>
+                </a:solidFill>
+                <a:latin typeface="Segoe UI"/>
+              </a:rPr>
+              <a:t>Venue &amp; City</a:t>
+            </a:r>
+          </a:p>
+        </p:txBody>
+      </p:sp>
+      <p:sp>
+        <p:nvSpPr>
+          <p:cNvPr id="84" name="Rectangle 83"/>
+          <p:cNvSpPr/>
+          <p:nvPr/>
+        </p:nvSpPr>
+        <p:spPr>
+          <a:xfrm>
+            <a:off x="3630168" y="4661611"/>
+            <a:ext cx="86867" cy="20116"/>
+          </a:xfrm>
+          <a:prstGeom prst="rect">
+            <a:avLst/>
+          </a:prstGeom>
+          <a:solidFill>
+            <a:srgbClr val="D48F0A"/>
+          </a:solidFill>
+          <a:ln>
+            <a:noFill/>
+          </a:ln>
+        </p:spPr>
+        <p:style>
+          <a:lnRef idx="1">
+            <a:schemeClr val="accent1"/>
+          </a:lnRef>
+          <a:fillRef idx="3">
+            <a:schemeClr val="accent1"/>
+          </a:fillRef>
+          <a:effectRef idx="2">
+            <a:schemeClr val="accent1"/>
+          </a:effectRef>
+          <a:fontRef idx="minor">
+            <a:schemeClr val="lt1"/>
+          </a:fontRef>
+        </p:style>
+        <p:txBody>
+          <a:bodyPr rtlCol="0" anchor="ctr"/>
+          <a:lstStyle/>
+          <a:p>
+            <a:pPr algn="ctr"/>
+          </a:p>
+        </p:txBody>
+      </p:sp>
+      <p:sp>
+        <p:nvSpPr>
+          <p:cNvPr id="85" name="Rounded Rectangle 84"/>
+          <p:cNvSpPr/>
+          <p:nvPr/>
+        </p:nvSpPr>
+        <p:spPr>
+          <a:xfrm>
+            <a:off x="3703320" y="4507992"/>
+            <a:ext cx="2194560" cy="329184"/>
+          </a:xfrm>
+          <a:prstGeom prst="roundRect">
+            <a:avLst/>
+          </a:prstGeom>
+          <a:solidFill>
+            <a:srgbClr val="EDF2F7"/>
+          </a:solidFill>
+          <a:ln w="9525">
+            <a:solidFill>
+              <a:srgbClr val="D48F0A"/>
+            </a:solidFill>
+          </a:ln>
+        </p:spPr>
+        <p:style>
+          <a:lnRef idx="1">
+            <a:schemeClr val="accent1"/>
+          </a:lnRef>
+          <a:fillRef idx="3">
+            <a:schemeClr val="accent1"/>
+          </a:fillRef>
+          <a:effectRef idx="2">
+            <a:schemeClr val="accent1"/>
+          </a:effectRef>
+          <a:fontRef idx="minor">
+            <a:schemeClr val="lt1"/>
+          </a:fontRef>
+        </p:style>
+        <p:txBody>
+          <a:bodyPr rtlCol="0" anchor="ctr"/>
+          <a:lstStyle/>
+          <a:p>
+            <a:pPr algn="ctr"/>
+          </a:p>
+        </p:txBody>
+      </p:sp>
+      <p:sp>
+        <p:nvSpPr>
+          <p:cNvPr id="86" name="TextBox 85"/>
+          <p:cNvSpPr txBox="1"/>
+          <p:nvPr/>
+        </p:nvSpPr>
+        <p:spPr>
+          <a:xfrm>
+            <a:off x="3794759" y="4544568"/>
+            <a:ext cx="2011679" cy="256031"/>
+          </a:xfrm>
+          <a:prstGeom prst="rect">
+            <a:avLst/>
+          </a:prstGeom>
+          <a:noFill/>
+        </p:spPr>
+        <p:txBody>
+          <a:bodyPr wrap="square">
+            <a:spAutoFit/>
+          </a:bodyPr>
+          <a:lstStyle/>
+          <a:p>
+            <a:pPr algn="l"/>
+            <a:r>
+              <a:rPr sz="800" b="0" i="0">
+                <a:solidFill>
+                  <a:srgbClr val="1A1A1A"/>
+                </a:solidFill>
+                <a:latin typeface="Segoe UI"/>
+              </a:rPr>
+              <a:t>Ticket Inventory</a:t>
+            </a:r>
+          </a:p>
+        </p:txBody>
+      </p:sp>
+      <p:sp>
+        <p:nvSpPr>
+          <p:cNvPr id="87" name="Rectangle 86"/>
+          <p:cNvSpPr/>
+          <p:nvPr/>
+        </p:nvSpPr>
+        <p:spPr>
+          <a:xfrm>
+            <a:off x="3630168" y="5045659"/>
+            <a:ext cx="86867" cy="20116"/>
+          </a:xfrm>
+          <a:prstGeom prst="rect">
+            <a:avLst/>
+          </a:prstGeom>
+          <a:solidFill>
+            <a:srgbClr val="D48F0A"/>
+          </a:solidFill>
+          <a:ln>
+            <a:noFill/>
+          </a:ln>
+        </p:spPr>
+        <p:style>
+          <a:lnRef idx="1">
+            <a:schemeClr val="accent1"/>
+          </a:lnRef>
+          <a:fillRef idx="3">
+            <a:schemeClr val="accent1"/>
+          </a:fillRef>
+          <a:effectRef idx="2">
+            <a:schemeClr val="accent1"/>
+          </a:effectRef>
+          <a:fontRef idx="minor">
+            <a:schemeClr val="lt1"/>
+          </a:fontRef>
+        </p:style>
+        <p:txBody>
+          <a:bodyPr rtlCol="0" anchor="ctr"/>
+          <a:lstStyle/>
+          <a:p>
+            <a:pPr algn="ctr"/>
+          </a:p>
+        </p:txBody>
+      </p:sp>
+      <p:sp>
+        <p:nvSpPr>
+          <p:cNvPr id="88" name="Rounded Rectangle 87"/>
+          <p:cNvSpPr/>
+          <p:nvPr/>
+        </p:nvSpPr>
+        <p:spPr>
+          <a:xfrm>
+            <a:off x="3703320" y="4892040"/>
+            <a:ext cx="2194560" cy="329184"/>
+          </a:xfrm>
+          <a:prstGeom prst="roundRect">
+            <a:avLst/>
+          </a:prstGeom>
+          <a:solidFill>
+            <a:srgbClr val="EDF2F7"/>
+          </a:solidFill>
+          <a:ln w="9525">
+            <a:solidFill>
+              <a:srgbClr val="D48F0A"/>
+            </a:solidFill>
+          </a:ln>
+        </p:spPr>
+        <p:style>
+          <a:lnRef idx="1">
+            <a:schemeClr val="accent1"/>
+          </a:lnRef>
+          <a:fillRef idx="3">
+            <a:schemeClr val="accent1"/>
+          </a:fillRef>
+          <a:effectRef idx="2">
+            <a:schemeClr val="accent1"/>
+          </a:effectRef>
+          <a:fontRef idx="minor">
+            <a:schemeClr val="lt1"/>
+          </a:fontRef>
+        </p:style>
+        <p:txBody>
+          <a:bodyPr rtlCol="0" anchor="ctr"/>
+          <a:lstStyle/>
+          <a:p>
+            <a:pPr algn="ctr"/>
+          </a:p>
+        </p:txBody>
+      </p:sp>
+      <p:sp>
+        <p:nvSpPr>
+          <p:cNvPr id="89" name="TextBox 88"/>
+          <p:cNvSpPr txBox="1"/>
+          <p:nvPr/>
+        </p:nvSpPr>
+        <p:spPr>
+          <a:xfrm>
+            <a:off x="3794759" y="4928616"/>
+            <a:ext cx="2011679" cy="256031"/>
+          </a:xfrm>
+          <a:prstGeom prst="rect">
+            <a:avLst/>
+          </a:prstGeom>
+          <a:noFill/>
+        </p:spPr>
+        <p:txBody>
+          <a:bodyPr wrap="square">
+            <a:spAutoFit/>
+          </a:bodyPr>
+          <a:lstStyle/>
+          <a:p>
+            <a:pPr algn="l"/>
+            <a:r>
+              <a:rPr sz="800" b="0" i="0">
+                <a:solidFill>
+                  <a:srgbClr val="1A1A1A"/>
+                </a:solidFill>
+                <a:latin typeface="Segoe UI"/>
+              </a:rPr>
+              <a:t>Live Photography</a:t>
+            </a:r>
+          </a:p>
+        </p:txBody>
+      </p:sp>
+      <p:sp>
+        <p:nvSpPr>
+          <p:cNvPr id="90" name="Rectangle 89"/>
+          <p:cNvSpPr/>
+          <p:nvPr/>
+        </p:nvSpPr>
+        <p:spPr>
+          <a:xfrm>
+            <a:off x="1892807" y="5868619"/>
+            <a:ext cx="86868" cy="20116"/>
+          </a:xfrm>
+          <a:prstGeom prst="rect">
+            <a:avLst/>
+          </a:prstGeom>
+          <a:solidFill>
+            <a:srgbClr val="4A90E2"/>
+          </a:solidFill>
+          <a:ln>
+            <a:noFill/>
+          </a:ln>
+        </p:spPr>
+        <p:style>
+          <a:lnRef idx="1">
+            <a:schemeClr val="accent1"/>
+          </a:lnRef>
+          <a:fillRef idx="3">
+            <a:schemeClr val="accent1"/>
+          </a:fillRef>
+          <a:effectRef idx="2">
+            <a:schemeClr val="accent1"/>
+          </a:effectRef>
+          <a:fontRef idx="minor">
+            <a:schemeClr val="lt1"/>
+          </a:fontRef>
+        </p:style>
+        <p:txBody>
+          <a:bodyPr rtlCol="0" anchor="ctr"/>
+          <a:lstStyle/>
+          <a:p>
+            <a:pPr algn="ctr"/>
+          </a:p>
+        </p:txBody>
+      </p:sp>
+      <p:sp>
+        <p:nvSpPr>
+          <p:cNvPr id="91" name="Rounded Rectangle 90"/>
+          <p:cNvSpPr/>
+          <p:nvPr/>
+        </p:nvSpPr>
+        <p:spPr>
+          <a:xfrm>
+            <a:off x="1965960" y="5687568"/>
+            <a:ext cx="1463040" cy="384048"/>
+          </a:xfrm>
+          <a:prstGeom prst="roundRect">
+            <a:avLst/>
+          </a:prstGeom>
+          <a:solidFill>
+            <a:srgbClr val="4A90E2"/>
+          </a:solidFill>
+          <a:ln w="12700">
+            <a:solidFill>
+              <a:srgbClr val="4A90E2"/>
+            </a:solidFill>
+          </a:ln>
+        </p:spPr>
+        <p:style>
+          <a:lnRef idx="1">
+            <a:schemeClr val="accent1"/>
+          </a:lnRef>
+          <a:fillRef idx="3">
+            <a:schemeClr val="accent1"/>
+          </a:fillRef>
+          <a:effectRef idx="2">
+            <a:schemeClr val="accent1"/>
+          </a:effectRef>
+          <a:fontRef idx="minor">
+            <a:schemeClr val="lt1"/>
+          </a:fontRef>
+        </p:style>
+        <p:txBody>
+          <a:bodyPr rtlCol="0" anchor="ctr"/>
+          <a:lstStyle/>
+          <a:p>
+            <a:pPr algn="ctr"/>
+          </a:p>
+        </p:txBody>
+      </p:sp>
+      <p:sp>
+        <p:nvSpPr>
+          <p:cNvPr id="92" name="TextBox 91"/>
+          <p:cNvSpPr txBox="1"/>
+          <p:nvPr/>
+        </p:nvSpPr>
+        <p:spPr>
+          <a:xfrm>
+            <a:off x="1965960" y="5687568"/>
+            <a:ext cx="1463040" cy="384048"/>
+          </a:xfrm>
+          <a:prstGeom prst="rect">
+            <a:avLst/>
+          </a:prstGeom>
+          <a:noFill/>
+        </p:spPr>
+        <p:txBody>
+          <a:bodyPr wrap="square">
+            <a:spAutoFit/>
+          </a:bodyPr>
+          <a:lstStyle/>
+          <a:p>
+            <a:pPr algn="ctr"/>
+            <a:r>
+              <a:rPr sz="900" b="1" i="0">
+                <a:solidFill>
+                  <a:srgbClr val="FFFFFF"/>
+                </a:solidFill>
+                <a:latin typeface="Segoe UI"/>
+              </a:rPr>
+              <a:t>Contact</a:t>
+            </a:r>
+          </a:p>
+        </p:txBody>
+      </p:sp>
+      <p:sp>
+        <p:nvSpPr>
+          <p:cNvPr id="93" name="Rectangle 92"/>
+          <p:cNvSpPr/>
+          <p:nvPr/>
+        </p:nvSpPr>
+        <p:spPr>
+          <a:xfrm>
+            <a:off x="3619195" y="5495544"/>
+            <a:ext cx="20116" cy="781811"/>
+          </a:xfrm>
+          <a:prstGeom prst="rect">
+            <a:avLst/>
+          </a:prstGeom>
+          <a:solidFill>
+            <a:srgbClr val="4A90E2"/>
+          </a:solidFill>
+          <a:ln>
+            <a:noFill/>
+          </a:ln>
+        </p:spPr>
+        <p:style>
+          <a:lnRef idx="1">
+            <a:schemeClr val="accent1"/>
+          </a:lnRef>
+          <a:fillRef idx="3">
+            <a:schemeClr val="accent1"/>
+          </a:fillRef>
+          <a:effectRef idx="2">
+            <a:schemeClr val="accent1"/>
+          </a:effectRef>
+          <a:fontRef idx="minor">
+            <a:schemeClr val="lt1"/>
+          </a:fontRef>
+        </p:style>
+        <p:txBody>
+          <a:bodyPr rtlCol="0" anchor="ctr"/>
+          <a:lstStyle/>
+          <a:p>
+            <a:pPr algn="ctr"/>
+          </a:p>
+        </p:txBody>
+      </p:sp>
+      <p:sp>
+        <p:nvSpPr>
+          <p:cNvPr id="94" name="Rectangle 93"/>
+          <p:cNvSpPr/>
+          <p:nvPr/>
+        </p:nvSpPr>
+        <p:spPr>
+          <a:xfrm>
+            <a:off x="3429000" y="5868619"/>
+            <a:ext cx="214884" cy="20116"/>
+          </a:xfrm>
+          <a:prstGeom prst="rect">
+            <a:avLst/>
+          </a:prstGeom>
+          <a:solidFill>
+            <a:srgbClr val="4A90E2"/>
+          </a:solidFill>
+          <a:ln>
+            <a:noFill/>
+          </a:ln>
+        </p:spPr>
+        <p:style>
+          <a:lnRef idx="1">
+            <a:schemeClr val="accent1"/>
+          </a:lnRef>
+          <a:fillRef idx="3">
+            <a:schemeClr val="accent1"/>
+          </a:fillRef>
+          <a:effectRef idx="2">
+            <a:schemeClr val="accent1"/>
+          </a:effectRef>
+          <a:fontRef idx="minor">
+            <a:schemeClr val="lt1"/>
+          </a:fontRef>
+        </p:style>
+        <p:txBody>
+          <a:bodyPr rtlCol="0" anchor="ctr"/>
+          <a:lstStyle/>
+          <a:p>
+            <a:pPr algn="ctr"/>
+          </a:p>
+        </p:txBody>
+      </p:sp>
+      <p:sp>
+        <p:nvSpPr>
+          <p:cNvPr id="95" name="Rectangle 94"/>
+          <p:cNvSpPr/>
+          <p:nvPr/>
+        </p:nvSpPr>
+        <p:spPr>
+          <a:xfrm>
+            <a:off x="3630168" y="5484571"/>
+            <a:ext cx="86867" cy="20116"/>
+          </a:xfrm>
+          <a:prstGeom prst="rect">
+            <a:avLst/>
+          </a:prstGeom>
+          <a:solidFill>
+            <a:srgbClr val="4A90E2"/>
+          </a:solidFill>
+          <a:ln>
+            <a:noFill/>
+          </a:ln>
+        </p:spPr>
+        <p:style>
+          <a:lnRef idx="1">
+            <a:schemeClr val="accent1"/>
+          </a:lnRef>
+          <a:fillRef idx="3">
+            <a:schemeClr val="accent1"/>
+          </a:fillRef>
+          <a:effectRef idx="2">
+            <a:schemeClr val="accent1"/>
+          </a:effectRef>
+          <a:fontRef idx="minor">
+            <a:schemeClr val="lt1"/>
+          </a:fontRef>
+        </p:style>
+        <p:txBody>
+          <a:bodyPr rtlCol="0" anchor="ctr"/>
+          <a:lstStyle/>
+          <a:p>
+            <a:pPr algn="ctr"/>
+          </a:p>
+        </p:txBody>
+      </p:sp>
+      <p:sp>
+        <p:nvSpPr>
+          <p:cNvPr id="96" name="Rounded Rectangle 95"/>
+          <p:cNvSpPr/>
+          <p:nvPr/>
+        </p:nvSpPr>
+        <p:spPr>
+          <a:xfrm>
+            <a:off x="3703320" y="5330952"/>
+            <a:ext cx="2194560" cy="329184"/>
+          </a:xfrm>
+          <a:prstGeom prst="roundRect">
+            <a:avLst/>
+          </a:prstGeom>
+          <a:solidFill>
+            <a:srgbClr val="EDF2F7"/>
+          </a:solidFill>
+          <a:ln w="9525">
+            <a:solidFill>
+              <a:srgbClr val="4A90E2"/>
+            </a:solidFill>
+          </a:ln>
+        </p:spPr>
+        <p:style>
+          <a:lnRef idx="1">
+            <a:schemeClr val="accent1"/>
+          </a:lnRef>
+          <a:fillRef idx="3">
+            <a:schemeClr val="accent1"/>
+          </a:fillRef>
+          <a:effectRef idx="2">
+            <a:schemeClr val="accent1"/>
+          </a:effectRef>
+          <a:fontRef idx="minor">
+            <a:schemeClr val="lt1"/>
+          </a:fontRef>
+        </p:style>
+        <p:txBody>
+          <a:bodyPr rtlCol="0" anchor="ctr"/>
+          <a:lstStyle/>
+          <a:p>
+            <a:pPr algn="ctr"/>
+          </a:p>
+        </p:txBody>
+      </p:sp>
+      <p:sp>
+        <p:nvSpPr>
+          <p:cNvPr id="97" name="TextBox 96"/>
+          <p:cNvSpPr txBox="1"/>
+          <p:nvPr/>
+        </p:nvSpPr>
+        <p:spPr>
+          <a:xfrm>
+            <a:off x="3794759" y="5367528"/>
+            <a:ext cx="2011679" cy="256031"/>
+          </a:xfrm>
+          <a:prstGeom prst="rect">
+            <a:avLst/>
+          </a:prstGeom>
+          <a:noFill/>
+        </p:spPr>
+        <p:txBody>
+          <a:bodyPr wrap="square">
+            <a:spAutoFit/>
+          </a:bodyPr>
+          <a:lstStyle/>
+          <a:p>
+            <a:pPr algn="l"/>
+            <a:r>
+              <a:rPr sz="800" b="0" i="0">
+                <a:solidFill>
+                  <a:srgbClr val="1A1A1A"/>
+                </a:solidFill>
+                <a:latin typeface="Segoe UI"/>
+              </a:rPr>
+              <a:t>Inquiry Form Fields</a:t>
+            </a:r>
+          </a:p>
+        </p:txBody>
+      </p:sp>
+      <p:sp>
+        <p:nvSpPr>
+          <p:cNvPr id="98" name="Rectangle 97"/>
+          <p:cNvSpPr/>
+          <p:nvPr/>
+        </p:nvSpPr>
+        <p:spPr>
+          <a:xfrm>
+            <a:off x="3630168" y="5868619"/>
+            <a:ext cx="86867" cy="20116"/>
+          </a:xfrm>
+          <a:prstGeom prst="rect">
+            <a:avLst/>
+          </a:prstGeom>
+          <a:solidFill>
+            <a:srgbClr val="4A90E2"/>
+          </a:solidFill>
+          <a:ln>
+            <a:noFill/>
+          </a:ln>
+        </p:spPr>
+        <p:style>
+          <a:lnRef idx="1">
+            <a:schemeClr val="accent1"/>
+          </a:lnRef>
+          <a:fillRef idx="3">
+            <a:schemeClr val="accent1"/>
+          </a:fillRef>
+          <a:effectRef idx="2">
+            <a:schemeClr val="accent1"/>
+          </a:effectRef>
+          <a:fontRef idx="minor">
+            <a:schemeClr val="lt1"/>
+          </a:fontRef>
+        </p:style>
+        <p:txBody>
+          <a:bodyPr rtlCol="0" anchor="ctr"/>
+          <a:lstStyle/>
+          <a:p>
+            <a:pPr algn="ctr"/>
+          </a:p>
+        </p:txBody>
+      </p:sp>
+      <p:sp>
+        <p:nvSpPr>
+          <p:cNvPr id="99" name="Rounded Rectangle 98"/>
+          <p:cNvSpPr/>
+          <p:nvPr/>
+        </p:nvSpPr>
+        <p:spPr>
+          <a:xfrm>
+            <a:off x="3703320" y="5715000"/>
+            <a:ext cx="2194560" cy="329184"/>
+          </a:xfrm>
+          <a:prstGeom prst="roundRect">
+            <a:avLst/>
+          </a:prstGeom>
+          <a:solidFill>
+            <a:srgbClr val="EDF2F7"/>
+          </a:solidFill>
+          <a:ln w="9525">
+            <a:solidFill>
+              <a:srgbClr val="4A90E2"/>
+            </a:solidFill>
+          </a:ln>
+        </p:spPr>
+        <p:style>
+          <a:lnRef idx="1">
+            <a:schemeClr val="accent1"/>
+          </a:lnRef>
+          <a:fillRef idx="3">
+            <a:schemeClr val="accent1"/>
+          </a:fillRef>
+          <a:effectRef idx="2">
+            <a:schemeClr val="accent1"/>
+          </a:effectRef>
+          <a:fontRef idx="minor">
+            <a:schemeClr val="lt1"/>
+          </a:fontRef>
+        </p:style>
+        <p:txBody>
+          <a:bodyPr rtlCol="0" anchor="ctr"/>
+          <a:lstStyle/>
+          <a:p>
+            <a:pPr algn="ctr"/>
+          </a:p>
+        </p:txBody>
+      </p:sp>
+      <p:sp>
+        <p:nvSpPr>
+          <p:cNvPr id="100" name="TextBox 99"/>
+          <p:cNvSpPr txBox="1"/>
+          <p:nvPr/>
+        </p:nvSpPr>
+        <p:spPr>
+          <a:xfrm>
+            <a:off x="3794759" y="5751576"/>
+            <a:ext cx="2011679" cy="256031"/>
+          </a:xfrm>
+          <a:prstGeom prst="rect">
+            <a:avLst/>
+          </a:prstGeom>
+          <a:noFill/>
+        </p:spPr>
+        <p:txBody>
+          <a:bodyPr wrap="square">
+            <a:spAutoFit/>
+          </a:bodyPr>
+          <a:lstStyle/>
+          <a:p>
+            <a:pPr algn="l"/>
+            <a:r>
+              <a:rPr sz="800" b="0" i="0">
+                <a:solidFill>
+                  <a:srgbClr val="1A1A1A"/>
+                </a:solidFill>
+                <a:latin typeface="Segoe UI"/>
+              </a:rPr>
+              <a:t>Confirmation Templates</a:t>
+            </a:r>
+          </a:p>
+        </p:txBody>
+      </p:sp>
+      <p:sp>
+        <p:nvSpPr>
+          <p:cNvPr id="101" name="Rectangle 100"/>
+          <p:cNvSpPr/>
+          <p:nvPr/>
+        </p:nvSpPr>
+        <p:spPr>
+          <a:xfrm>
+            <a:off x="3630168" y="6252667"/>
+            <a:ext cx="86867" cy="20116"/>
+          </a:xfrm>
+          <a:prstGeom prst="rect">
+            <a:avLst/>
+          </a:prstGeom>
+          <a:solidFill>
+            <a:srgbClr val="4A90E2"/>
+          </a:solidFill>
+          <a:ln>
+            <a:noFill/>
+          </a:ln>
+        </p:spPr>
+        <p:style>
+          <a:lnRef idx="1">
+            <a:schemeClr val="accent1"/>
+          </a:lnRef>
+          <a:fillRef idx="3">
+            <a:schemeClr val="accent1"/>
+          </a:fillRef>
+          <a:effectRef idx="2">
+            <a:schemeClr val="accent1"/>
+          </a:effectRef>
+          <a:fontRef idx="minor">
+            <a:schemeClr val="lt1"/>
+          </a:fontRef>
+        </p:style>
+        <p:txBody>
+          <a:bodyPr rtlCol="0" anchor="ctr"/>
+          <a:lstStyle/>
+          <a:p>
+            <a:pPr algn="ctr"/>
+          </a:p>
+        </p:txBody>
+      </p:sp>
+      <p:sp>
+        <p:nvSpPr>
+          <p:cNvPr id="102" name="Rounded Rectangle 101"/>
+          <p:cNvSpPr/>
+          <p:nvPr/>
+        </p:nvSpPr>
+        <p:spPr>
+          <a:xfrm>
+            <a:off x="3703320" y="6099048"/>
+            <a:ext cx="2194560" cy="329184"/>
+          </a:xfrm>
+          <a:prstGeom prst="roundRect">
+            <a:avLst/>
+          </a:prstGeom>
+          <a:solidFill>
+            <a:srgbClr val="EDF2F7"/>
+          </a:solidFill>
+          <a:ln w="9525">
+            <a:solidFill>
+              <a:srgbClr val="4A90E2"/>
+            </a:solidFill>
+          </a:ln>
+        </p:spPr>
+        <p:style>
+          <a:lnRef idx="1">
+            <a:schemeClr val="accent1"/>
+          </a:lnRef>
+          <a:fillRef idx="3">
+            <a:schemeClr val="accent1"/>
+          </a:fillRef>
+          <a:effectRef idx="2">
+            <a:schemeClr val="accent1"/>
+          </a:effectRef>
+          <a:fontRef idx="minor">
+            <a:schemeClr val="lt1"/>
+          </a:fontRef>
+        </p:style>
+        <p:txBody>
+          <a:bodyPr rtlCol="0" anchor="ctr"/>
+          <a:lstStyle/>
+          <a:p>
+            <a:pPr algn="ctr"/>
+          </a:p>
+        </p:txBody>
+      </p:sp>
+      <p:sp>
+        <p:nvSpPr>
+          <p:cNvPr id="103" name="TextBox 102"/>
+          <p:cNvSpPr txBox="1"/>
+          <p:nvPr/>
+        </p:nvSpPr>
+        <p:spPr>
+          <a:xfrm>
+            <a:off x="3794759" y="6135624"/>
+            <a:ext cx="2011679" cy="256031"/>
+          </a:xfrm>
+          <a:prstGeom prst="rect">
+            <a:avLst/>
+          </a:prstGeom>
+          <a:noFill/>
+        </p:spPr>
+        <p:txBody>
+          <a:bodyPr wrap="square">
+            <a:spAutoFit/>
+          </a:bodyPr>
+          <a:lstStyle/>
+          <a:p>
+            <a:pPr algn="l"/>
+            <a:r>
+              <a:rPr sz="800" b="0" i="0">
+                <a:solidFill>
+                  <a:srgbClr val="1A1A1A"/>
+                </a:solidFill>
+                <a:latin typeface="Segoe UI"/>
+              </a:rPr>
+              <a:t>Email Notifications</a:t>
+            </a:r>
+          </a:p>
+        </p:txBody>
+      </p:sp>
+      <p:sp>
+        <p:nvSpPr>
+          <p:cNvPr id="104" name="Rectangle 103"/>
+          <p:cNvSpPr/>
+          <p:nvPr/>
+        </p:nvSpPr>
+        <p:spPr>
+          <a:xfrm>
+            <a:off x="6088075" y="6071616"/>
+            <a:ext cx="20116" cy="397763"/>
+          </a:xfrm>
+          <a:prstGeom prst="rect">
+            <a:avLst/>
+          </a:prstGeom>
+          <a:solidFill>
+            <a:srgbClr val="4A90E2"/>
+          </a:solidFill>
+          <a:ln>
+            <a:noFill/>
+          </a:ln>
+        </p:spPr>
+        <p:style>
+          <a:lnRef idx="1">
+            <a:schemeClr val="accent1"/>
+          </a:lnRef>
+          <a:fillRef idx="3">
+            <a:schemeClr val="accent1"/>
+          </a:fillRef>
+          <a:effectRef idx="2">
+            <a:schemeClr val="accent1"/>
+          </a:effectRef>
+          <a:fontRef idx="minor">
+            <a:schemeClr val="lt1"/>
+          </a:fontRef>
+        </p:style>
+        <p:txBody>
+          <a:bodyPr rtlCol="0" anchor="ctr"/>
+          <a:lstStyle/>
+          <a:p>
+            <a:pPr algn="ctr"/>
+          </a:p>
+        </p:txBody>
+      </p:sp>
+      <p:sp>
+        <p:nvSpPr>
+          <p:cNvPr id="105" name="Rectangle 104"/>
+          <p:cNvSpPr/>
+          <p:nvPr/>
+        </p:nvSpPr>
+        <p:spPr>
+          <a:xfrm>
+            <a:off x="5897879" y="6252667"/>
+            <a:ext cx="214884" cy="20116"/>
+          </a:xfrm>
+          <a:prstGeom prst="rect">
+            <a:avLst/>
+          </a:prstGeom>
+          <a:solidFill>
+            <a:srgbClr val="4A90E2"/>
+          </a:solidFill>
+          <a:ln>
+            <a:noFill/>
+          </a:ln>
+        </p:spPr>
+        <p:style>
+          <a:lnRef idx="1">
+            <a:schemeClr val="accent1"/>
+          </a:lnRef>
+          <a:fillRef idx="3">
+            <a:schemeClr val="accent1"/>
+          </a:fillRef>
+          <a:effectRef idx="2">
+            <a:schemeClr val="accent1"/>
+          </a:effectRef>
+          <a:fontRef idx="minor">
+            <a:schemeClr val="lt1"/>
+          </a:fontRef>
+        </p:style>
+        <p:txBody>
+          <a:bodyPr rtlCol="0" anchor="ctr"/>
+          <a:lstStyle/>
+          <a:p>
+            <a:pPr algn="ctr"/>
+          </a:p>
+        </p:txBody>
+      </p:sp>
+      <p:sp>
+        <p:nvSpPr>
+          <p:cNvPr id="106" name="Rectangle 105"/>
+          <p:cNvSpPr/>
+          <p:nvPr/>
+        </p:nvSpPr>
+        <p:spPr>
+          <a:xfrm>
+            <a:off x="6099048" y="6060643"/>
+            <a:ext cx="86868" cy="20116"/>
+          </a:xfrm>
+          <a:prstGeom prst="rect">
+            <a:avLst/>
+          </a:prstGeom>
+          <a:solidFill>
+            <a:srgbClr val="4A90E2"/>
+          </a:solidFill>
+          <a:ln>
+            <a:noFill/>
+          </a:ln>
+        </p:spPr>
+        <p:style>
+          <a:lnRef idx="1">
+            <a:schemeClr val="accent1"/>
+          </a:lnRef>
+          <a:fillRef idx="3">
+            <a:schemeClr val="accent1"/>
+          </a:fillRef>
+          <a:effectRef idx="2">
+            <a:schemeClr val="accent1"/>
+          </a:effectRef>
+          <a:fontRef idx="minor">
+            <a:schemeClr val="lt1"/>
+          </a:fontRef>
+        </p:style>
+        <p:txBody>
+          <a:bodyPr rtlCol="0" anchor="ctr"/>
+          <a:lstStyle/>
+          <a:p>
+            <a:pPr algn="ctr"/>
+          </a:p>
+        </p:txBody>
+      </p:sp>
+      <p:sp>
+        <p:nvSpPr>
+          <p:cNvPr id="107" name="Rounded Rectangle 106"/>
+          <p:cNvSpPr/>
+          <p:nvPr/>
+        </p:nvSpPr>
+        <p:spPr>
+          <a:xfrm>
+            <a:off x="6172200" y="5907024"/>
+            <a:ext cx="2011680" cy="329184"/>
+          </a:xfrm>
+          <a:prstGeom prst="roundRect">
+            <a:avLst/>
+          </a:prstGeom>
+          <a:solidFill>
+            <a:srgbClr val="F5F8FC"/>
+          </a:solidFill>
+          <a:ln w="9525">
+            <a:solidFill>
+              <a:srgbClr val="4A90E2"/>
+            </a:solidFill>
+          </a:ln>
+        </p:spPr>
+        <p:style>
+          <a:lnRef idx="1">
+            <a:schemeClr val="accent1"/>
+          </a:lnRef>
+          <a:fillRef idx="3">
+            <a:schemeClr val="accent1"/>
+          </a:fillRef>
+          <a:effectRef idx="2">
+            <a:schemeClr val="accent1"/>
+          </a:effectRef>
+          <a:fontRef idx="minor">
+            <a:schemeClr val="lt1"/>
+          </a:fontRef>
+        </p:style>
+        <p:txBody>
+          <a:bodyPr rtlCol="0" anchor="ctr"/>
+          <a:lstStyle/>
+          <a:p>
+            <a:pPr algn="ctr"/>
+          </a:p>
+        </p:txBody>
+      </p:sp>
+      <p:sp>
+        <p:nvSpPr>
+          <p:cNvPr id="108" name="TextBox 107"/>
+          <p:cNvSpPr txBox="1"/>
+          <p:nvPr/>
+        </p:nvSpPr>
+        <p:spPr>
+          <a:xfrm>
+            <a:off x="6263640" y="5943600"/>
+            <a:ext cx="1828800" cy="256031"/>
+          </a:xfrm>
+          <a:prstGeom prst="rect">
+            <a:avLst/>
+          </a:prstGeom>
+          <a:noFill/>
+        </p:spPr>
+        <p:txBody>
+          <a:bodyPr wrap="square">
+            <a:spAutoFit/>
+          </a:bodyPr>
+          <a:lstStyle/>
+          <a:p>
+            <a:pPr algn="l"/>
+            <a:r>
+              <a:rPr sz="800" b="0" i="0">
+                <a:solidFill>
+                  <a:srgbClr val="6B7280"/>
+                </a:solidFill>
+                <a:latin typeface="Segoe UI"/>
+              </a:rPr>
+              <a:t>Welcome Email</a:t>
+            </a:r>
+          </a:p>
+        </p:txBody>
+      </p:sp>
+      <p:sp>
+        <p:nvSpPr>
+          <p:cNvPr id="109" name="Rectangle 108"/>
+          <p:cNvSpPr/>
+          <p:nvPr/>
+        </p:nvSpPr>
+        <p:spPr>
+          <a:xfrm>
+            <a:off x="6099048" y="6444691"/>
+            <a:ext cx="86868" cy="20116"/>
+          </a:xfrm>
+          <a:prstGeom prst="rect">
+            <a:avLst/>
+          </a:prstGeom>
+          <a:solidFill>
+            <a:srgbClr val="4A90E2"/>
+          </a:solidFill>
+          <a:ln>
+            <a:noFill/>
+          </a:ln>
+        </p:spPr>
+        <p:style>
+          <a:lnRef idx="1">
+            <a:schemeClr val="accent1"/>
+          </a:lnRef>
+          <a:fillRef idx="3">
+            <a:schemeClr val="accent1"/>
+          </a:fillRef>
+          <a:effectRef idx="2">
+            <a:schemeClr val="accent1"/>
+          </a:effectRef>
+          <a:fontRef idx="minor">
+            <a:schemeClr val="lt1"/>
+          </a:fontRef>
+        </p:style>
+        <p:txBody>
+          <a:bodyPr rtlCol="0" anchor="ctr"/>
+          <a:lstStyle/>
+          <a:p>
+            <a:pPr algn="ctr"/>
+          </a:p>
+        </p:txBody>
+      </p:sp>
+      <p:sp>
+        <p:nvSpPr>
+          <p:cNvPr id="110" name="Rounded Rectangle 109"/>
+          <p:cNvSpPr/>
+          <p:nvPr/>
+        </p:nvSpPr>
+        <p:spPr>
+          <a:xfrm>
+            <a:off x="6172200" y="6291072"/>
+            <a:ext cx="2011680" cy="329184"/>
+          </a:xfrm>
+          <a:prstGeom prst="roundRect">
+            <a:avLst/>
+          </a:prstGeom>
+          <a:solidFill>
+            <a:srgbClr val="F5F8FC"/>
+          </a:solidFill>
+          <a:ln w="9525">
+            <a:solidFill>
+              <a:srgbClr val="4A90E2"/>
+            </a:solidFill>
+          </a:ln>
+        </p:spPr>
+        <p:style>
+          <a:lnRef idx="1">
+            <a:schemeClr val="accent1"/>
+          </a:lnRef>
+          <a:fillRef idx="3">
+            <a:schemeClr val="accent1"/>
+          </a:fillRef>
+          <a:effectRef idx="2">
+            <a:schemeClr val="accent1"/>
+          </a:effectRef>
+          <a:fontRef idx="minor">
+            <a:schemeClr val="lt1"/>
+          </a:fontRef>
+        </p:style>
+        <p:txBody>
+          <a:bodyPr rtlCol="0" anchor="ctr"/>
+          <a:lstStyle/>
+          <a:p>
+            <a:pPr algn="ctr"/>
+          </a:p>
+        </p:txBody>
+      </p:sp>
+      <p:sp>
+        <p:nvSpPr>
+          <p:cNvPr id="111" name="TextBox 110"/>
+          <p:cNvSpPr txBox="1"/>
+          <p:nvPr/>
+        </p:nvSpPr>
+        <p:spPr>
+          <a:xfrm>
+            <a:off x="6263640" y="6327648"/>
+            <a:ext cx="1828800" cy="256031"/>
+          </a:xfrm>
+          <a:prstGeom prst="rect">
+            <a:avLst/>
+          </a:prstGeom>
+          <a:noFill/>
+        </p:spPr>
+        <p:txBody>
+          <a:bodyPr wrap="square">
+            <a:spAutoFit/>
+          </a:bodyPr>
+          <a:lstStyle/>
+          <a:p>
+            <a:pPr algn="l"/>
+            <a:r>
+              <a:rPr sz="800" b="0" i="0">
+                <a:solidFill>
+                  <a:srgbClr val="6B7280"/>
+                </a:solidFill>
+                <a:latin typeface="Segoe UI"/>
+              </a:rPr>
+              <a:t>Show Alerts</a:t>
+            </a:r>
+          </a:p>
+        </p:txBody>
+      </p:sp>
+      <p:sp>
+        <p:nvSpPr>
+          <p:cNvPr id="112" name="Rectangle 111"/>
           <p:cNvSpPr/>
           <p:nvPr/>
         </p:nvSpPr>

</xml_diff>